<commit_message>
docs: update AI SDLC platform engineering slides
Co-Authored-By: Claude Sonnet 5 <noreply@anthropic.com>
</commit_message>
<xml_diff>
--- a/resources/AI_SDLC_Platform_Eng_Slides.pptx
+++ b/resources/AI_SDLC_Platform_Eng_Slides.pptx
@@ -1565,16 +1565,40 @@
           </a:ln>
         </p:spPr>
       </p:sp>
-      <p:sp>
-        <p:nvSpPr>
-          <p:cNvPr id="17" name="Text 15"/>
-          <p:cNvSpPr/>
-          <p:nvPr/>
-        </p:nvSpPr>
-        <p:spPr>
-          <a:xfrm>
-            <a:off x="365760" y="3236976"/>
-            <a:ext cx="1261872" cy="292608"/>
+      <p:pic>
+        <p:nvPicPr>
+          <p:cNvPr id="17" name="Image 0" descr="logo-aws.png">    </p:cNvPr>
+          <p:cNvPicPr>
+            <a:picLocks noChangeAspect="1"/>
+          </p:cNvPicPr>
+          <p:nvPr/>
+        </p:nvPicPr>
+        <p:blipFill>
+          <a:blip r:embed="rId1"/>
+          <a:stretch>
+            <a:fillRect/>
+          </a:stretch>
+        </p:blipFill>
+        <p:spPr>
+          <a:xfrm>
+            <a:off x="859536" y="3429000"/>
+            <a:ext cx="274320" cy="274320"/>
+          </a:xfrm>
+          <a:prstGeom prst="rect">
+            <a:avLst/>
+          </a:prstGeom>
+        </p:spPr>
+      </p:pic>
+      <p:sp>
+        <p:nvSpPr>
+          <p:cNvPr id="18" name="Text 15"/>
+          <p:cNvSpPr/>
+          <p:nvPr/>
+        </p:nvSpPr>
+        <p:spPr>
+          <a:xfrm>
+            <a:off x="365760" y="3721608"/>
+            <a:ext cx="1261872" cy="146304"/>
           </a:xfrm>
           <a:prstGeom prst="rect">
             <a:avLst/>
@@ -1598,7 +1622,7 @@
                 <a:ea typeface="Arial" pitchFamily="34" charset="-122"/>
                 <a:cs typeface="Arial" pitchFamily="34" charset="-120"/>
               </a:rPr>
-              <a:t>AWS Bedrock AgentCore</a:t>
+              <a:t>AWS Bedrock</a:t>
             </a:r>
             <a:endParaRPr lang="en-US" sz="850" dirty="0"/>
           </a:p>
@@ -1606,14 +1630,14 @@
       </p:sp>
       <p:sp>
         <p:nvSpPr>
-          <p:cNvPr id="18" name="Text 16"/>
-          <p:cNvSpPr/>
-          <p:nvPr/>
-        </p:nvSpPr>
-        <p:spPr>
-          <a:xfrm>
-            <a:off x="365760" y="3520440"/>
-            <a:ext cx="1261872" cy="164592"/>
+          <p:cNvPr id="19" name="Text 16"/>
+          <p:cNvSpPr/>
+          <p:nvPr/>
+        </p:nvSpPr>
+        <p:spPr>
+          <a:xfrm>
+            <a:off x="365760" y="3858768"/>
+            <a:ext cx="1261872" cy="137160"/>
           </a:xfrm>
           <a:prstGeom prst="rect">
             <a:avLst/>
@@ -1629,7 +1653,7 @@
               <a:buNone/>
             </a:pPr>
             <a:r>
-              <a:rPr lang="en-US" sz="700" dirty="0">
+              <a:rPr lang="en-US" sz="650" dirty="0">
                 <a:solidFill>
                   <a:srgbClr val="5A5A5A"/>
                 </a:solidFill>
@@ -1637,22 +1661,46 @@
                 <a:ea typeface="Arial" pitchFamily="34" charset="-122"/>
                 <a:cs typeface="Arial" pitchFamily="34" charset="-120"/>
               </a:rPr>
-              <a:t>Agent Runtime</a:t>
-            </a:r>
-            <a:endParaRPr lang="en-US" sz="700" dirty="0"/>
-          </a:p>
-        </p:txBody>
-      </p:sp>
-      <p:sp>
-        <p:nvSpPr>
-          <p:cNvPr id="19" name="Text 17"/>
-          <p:cNvSpPr/>
-          <p:nvPr/>
-        </p:nvSpPr>
-        <p:spPr>
-          <a:xfrm>
-            <a:off x="1691640" y="3236976"/>
-            <a:ext cx="1261872" cy="292608"/>
+              <a:t>AgentCore Runtime</a:t>
+            </a:r>
+            <a:endParaRPr lang="en-US" sz="650" dirty="0"/>
+          </a:p>
+        </p:txBody>
+      </p:sp>
+      <p:pic>
+        <p:nvPicPr>
+          <p:cNvPr id="20" name="Image 1" descr="logo-temporal.png">    </p:cNvPr>
+          <p:cNvPicPr>
+            <a:picLocks noChangeAspect="1"/>
+          </p:cNvPicPr>
+          <p:nvPr/>
+        </p:nvPicPr>
+        <p:blipFill>
+          <a:blip r:embed="rId2"/>
+          <a:stretch>
+            <a:fillRect/>
+          </a:stretch>
+        </p:blipFill>
+        <p:spPr>
+          <a:xfrm>
+            <a:off x="2185416" y="3429000"/>
+            <a:ext cx="274320" cy="274320"/>
+          </a:xfrm>
+          <a:prstGeom prst="rect">
+            <a:avLst/>
+          </a:prstGeom>
+        </p:spPr>
+      </p:pic>
+      <p:sp>
+        <p:nvSpPr>
+          <p:cNvPr id="21" name="Text 17"/>
+          <p:cNvSpPr/>
+          <p:nvPr/>
+        </p:nvSpPr>
+        <p:spPr>
+          <a:xfrm>
+            <a:off x="1691640" y="3721608"/>
+            <a:ext cx="1261872" cy="146304"/>
           </a:xfrm>
           <a:prstGeom prst="rect">
             <a:avLst/>
@@ -1684,14 +1732,14 @@
       </p:sp>
       <p:sp>
         <p:nvSpPr>
-          <p:cNvPr id="20" name="Text 18"/>
-          <p:cNvSpPr/>
-          <p:nvPr/>
-        </p:nvSpPr>
-        <p:spPr>
-          <a:xfrm>
-            <a:off x="1691640" y="3520440"/>
-            <a:ext cx="1261872" cy="164592"/>
+          <p:cNvPr id="22" name="Text 18"/>
+          <p:cNvSpPr/>
+          <p:nvPr/>
+        </p:nvSpPr>
+        <p:spPr>
+          <a:xfrm>
+            <a:off x="1691640" y="3858768"/>
+            <a:ext cx="1261872" cy="137160"/>
           </a:xfrm>
           <a:prstGeom prst="rect">
             <a:avLst/>
@@ -1707,7 +1755,7 @@
               <a:buNone/>
             </a:pPr>
             <a:r>
-              <a:rPr lang="en-US" sz="700" dirty="0">
+              <a:rPr lang="en-US" sz="650" dirty="0">
                 <a:solidFill>
                   <a:srgbClr val="5A5A5A"/>
                 </a:solidFill>
@@ -1717,20 +1765,44 @@
               </a:rPr>
               <a:t>Durable Orchestration</a:t>
             </a:r>
-            <a:endParaRPr lang="en-US" sz="700" dirty="0"/>
-          </a:p>
-        </p:txBody>
-      </p:sp>
-      <p:sp>
-        <p:nvSpPr>
-          <p:cNvPr id="21" name="Text 19"/>
-          <p:cNvSpPr/>
-          <p:nvPr/>
-        </p:nvSpPr>
-        <p:spPr>
-          <a:xfrm>
-            <a:off x="365760" y="3749040"/>
-            <a:ext cx="1261872" cy="292608"/>
+            <a:endParaRPr lang="en-US" sz="650" dirty="0"/>
+          </a:p>
+        </p:txBody>
+      </p:sp>
+      <p:pic>
+        <p:nvPicPr>
+          <p:cNvPr id="23" name="Image 2" descr="logo-otel.png">    </p:cNvPr>
+          <p:cNvPicPr>
+            <a:picLocks noChangeAspect="1"/>
+          </p:cNvPicPr>
+          <p:nvPr/>
+        </p:nvPicPr>
+        <p:blipFill>
+          <a:blip r:embed="rId3"/>
+          <a:stretch>
+            <a:fillRect/>
+          </a:stretch>
+        </p:blipFill>
+        <p:spPr>
+          <a:xfrm>
+            <a:off x="859536" y="4087368"/>
+            <a:ext cx="274320" cy="274320"/>
+          </a:xfrm>
+          <a:prstGeom prst="rect">
+            <a:avLst/>
+          </a:prstGeom>
+        </p:spPr>
+      </p:pic>
+      <p:sp>
+        <p:nvSpPr>
+          <p:cNvPr id="24" name="Text 19"/>
+          <p:cNvSpPr/>
+          <p:nvPr/>
+        </p:nvSpPr>
+        <p:spPr>
+          <a:xfrm>
+            <a:off x="365760" y="4379976"/>
+            <a:ext cx="1261872" cy="146304"/>
           </a:xfrm>
           <a:prstGeom prst="rect">
             <a:avLst/>
@@ -1754,7 +1826,7 @@
                 <a:ea typeface="Arial" pitchFamily="34" charset="-122"/>
                 <a:cs typeface="Arial" pitchFamily="34" charset="-120"/>
               </a:rPr>
-              <a:t>Amazon EKS</a:t>
+              <a:t>OpenTelemetry</a:t>
             </a:r>
             <a:endParaRPr lang="en-US" sz="850" dirty="0"/>
           </a:p>
@@ -1762,14 +1834,14 @@
       </p:sp>
       <p:sp>
         <p:nvSpPr>
-          <p:cNvPr id="22" name="Text 20"/>
-          <p:cNvSpPr/>
-          <p:nvPr/>
-        </p:nvSpPr>
-        <p:spPr>
-          <a:xfrm>
-            <a:off x="365760" y="4032504"/>
-            <a:ext cx="1261872" cy="164592"/>
+          <p:cNvPr id="25" name="Text 20"/>
+          <p:cNvSpPr/>
+          <p:nvPr/>
+        </p:nvSpPr>
+        <p:spPr>
+          <a:xfrm>
+            <a:off x="365760" y="4517136"/>
+            <a:ext cx="1261872" cy="137160"/>
           </a:xfrm>
           <a:prstGeom prst="rect">
             <a:avLst/>
@@ -1785,7 +1857,7 @@
               <a:buNone/>
             </a:pPr>
             <a:r>
-              <a:rPr lang="en-US" sz="700" dirty="0">
+              <a:rPr lang="en-US" sz="650" dirty="0">
                 <a:solidFill>
                   <a:srgbClr val="5A5A5A"/>
                 </a:solidFill>
@@ -1793,171 +1865,15 @@
                 <a:ea typeface="Arial" pitchFamily="34" charset="-122"/>
                 <a:cs typeface="Arial" pitchFamily="34" charset="-120"/>
               </a:rPr>
-              <a:t>Platform Hosting</a:t>
-            </a:r>
-            <a:endParaRPr lang="en-US" sz="700" dirty="0"/>
-          </a:p>
-        </p:txBody>
-      </p:sp>
-      <p:sp>
-        <p:nvSpPr>
-          <p:cNvPr id="23" name="Text 21"/>
-          <p:cNvSpPr/>
-          <p:nvPr/>
-        </p:nvSpPr>
-        <p:spPr>
-          <a:xfrm>
-            <a:off x="1691640" y="3749040"/>
-            <a:ext cx="1261872" cy="292608"/>
-          </a:xfrm>
-          <a:prstGeom prst="rect">
-            <a:avLst/>
-          </a:prstGeom>
-          <a:noFill/>
-          <a:ln/>
-        </p:spPr>
-        <p:txBody>
-          <a:bodyPr wrap="square" lIns="0" tIns="0" rIns="0" bIns="0" rtlCol="0" anchor="ctr"/>
-          <a:lstStyle/>
-          <a:p>
-            <a:pPr algn="ctr" indent="0" marL="0">
-              <a:buNone/>
-            </a:pPr>
-            <a:r>
-              <a:rPr lang="en-US" sz="850" b="1" dirty="0">
-                <a:solidFill>
-                  <a:srgbClr val="1B365D"/>
-                </a:solidFill>
-                <a:latin typeface="Arial" pitchFamily="34" charset="0"/>
-                <a:ea typeface="Arial" pitchFamily="34" charset="-122"/>
-                <a:cs typeface="Arial" pitchFamily="34" charset="-120"/>
-              </a:rPr>
-              <a:t>Amazon CloudWatch</a:t>
-            </a:r>
-            <a:endParaRPr lang="en-US" sz="850" dirty="0"/>
-          </a:p>
-        </p:txBody>
-      </p:sp>
-      <p:sp>
-        <p:nvSpPr>
-          <p:cNvPr id="24" name="Text 22"/>
-          <p:cNvSpPr/>
-          <p:nvPr/>
-        </p:nvSpPr>
-        <p:spPr>
-          <a:xfrm>
-            <a:off x="1691640" y="4032504"/>
-            <a:ext cx="1261872" cy="164592"/>
-          </a:xfrm>
-          <a:prstGeom prst="rect">
-            <a:avLst/>
-          </a:prstGeom>
-          <a:noFill/>
-          <a:ln/>
-        </p:spPr>
-        <p:txBody>
-          <a:bodyPr wrap="square" lIns="0" tIns="0" rIns="0" bIns="0" rtlCol="0" anchor="ctr"/>
-          <a:lstStyle/>
-          <a:p>
-            <a:pPr algn="ctr" indent="0" marL="0">
-              <a:buNone/>
-            </a:pPr>
-            <a:r>
-              <a:rPr lang="en-US" sz="700" dirty="0">
-                <a:solidFill>
-                  <a:srgbClr val="5A5A5A"/>
-                </a:solidFill>
-                <a:latin typeface="Arial" pitchFamily="34" charset="0"/>
-                <a:ea typeface="Arial" pitchFamily="34" charset="-122"/>
-                <a:cs typeface="Arial" pitchFamily="34" charset="-120"/>
-              </a:rPr>
-              <a:t>Observability &amp; Metrics</a:t>
-            </a:r>
-            <a:endParaRPr lang="en-US" sz="700" dirty="0"/>
-          </a:p>
-        </p:txBody>
-      </p:sp>
-      <p:sp>
-        <p:nvSpPr>
-          <p:cNvPr id="25" name="Text 23"/>
-          <p:cNvSpPr/>
-          <p:nvPr/>
-        </p:nvSpPr>
-        <p:spPr>
-          <a:xfrm>
-            <a:off x="365760" y="4261104"/>
-            <a:ext cx="1261872" cy="292608"/>
-          </a:xfrm>
-          <a:prstGeom prst="rect">
-            <a:avLst/>
-          </a:prstGeom>
-          <a:noFill/>
-          <a:ln/>
-        </p:spPr>
-        <p:txBody>
-          <a:bodyPr wrap="square" lIns="0" tIns="0" rIns="0" bIns="0" rtlCol="0" anchor="ctr"/>
-          <a:lstStyle/>
-          <a:p>
-            <a:pPr algn="ctr" indent="0" marL="0">
-              <a:buNone/>
-            </a:pPr>
-            <a:r>
-              <a:rPr lang="en-US" sz="850" b="1" dirty="0">
-                <a:solidFill>
-                  <a:srgbClr val="1B365D"/>
-                </a:solidFill>
-                <a:latin typeface="Arial" pitchFamily="34" charset="0"/>
-                <a:ea typeface="Arial" pitchFamily="34" charset="-122"/>
-                <a:cs typeface="Arial" pitchFamily="34" charset="-120"/>
-              </a:rPr>
-              <a:t>GenAI API Marketplace</a:t>
-            </a:r>
-            <a:endParaRPr lang="en-US" sz="850" dirty="0"/>
-          </a:p>
-        </p:txBody>
-      </p:sp>
-      <p:sp>
-        <p:nvSpPr>
-          <p:cNvPr id="26" name="Text 24"/>
-          <p:cNvSpPr/>
-          <p:nvPr/>
-        </p:nvSpPr>
-        <p:spPr>
-          <a:xfrm>
-            <a:off x="365760" y="4544568"/>
-            <a:ext cx="1261872" cy="164592"/>
-          </a:xfrm>
-          <a:prstGeom prst="rect">
-            <a:avLst/>
-          </a:prstGeom>
-          <a:noFill/>
-          <a:ln/>
-        </p:spPr>
-        <p:txBody>
-          <a:bodyPr wrap="square" lIns="0" tIns="0" rIns="0" bIns="0" rtlCol="0" anchor="ctr"/>
-          <a:lstStyle/>
-          <a:p>
-            <a:pPr algn="ctr" indent="0" marL="0">
-              <a:buNone/>
-            </a:pPr>
-            <a:r>
-              <a:rPr lang="en-US" sz="700" dirty="0">
-                <a:solidFill>
-                  <a:srgbClr val="5A5A5A"/>
-                </a:solidFill>
-                <a:latin typeface="Arial" pitchFamily="34" charset="0"/>
-                <a:ea typeface="Arial" pitchFamily="34" charset="-122"/>
-                <a:cs typeface="Arial" pitchFamily="34" charset="-120"/>
-              </a:rPr>
-              <a:t>LLM Access</a:t>
-            </a:r>
-            <a:endParaRPr lang="en-US" sz="700" dirty="0"/>
-          </a:p>
-        </p:txBody>
-      </p:sp>
-      <p:sp>
-        <p:nvSpPr>
-          <p:cNvPr id="27" name="Shape 25"/>
+              <a:t>Agent Telemetry</a:t>
+            </a:r>
+            <a:endParaRPr lang="en-US" sz="650" dirty="0"/>
+          </a:p>
+        </p:txBody>
+      </p:sp>
+      <p:sp>
+        <p:nvSpPr>
+          <p:cNvPr id="26" name="Shape 21"/>
           <p:cNvSpPr/>
           <p:nvPr/>
         </p:nvSpPr>
@@ -1984,7 +1900,7 @@
       </p:sp>
       <p:sp>
         <p:nvSpPr>
-          <p:cNvPr id="28" name="Text 26"/>
+          <p:cNvPr id="27" name="Text 22"/>
           <p:cNvSpPr/>
           <p:nvPr/>
         </p:nvSpPr>
@@ -2023,7 +1939,7 @@
       </p:sp>
       <p:sp>
         <p:nvSpPr>
-          <p:cNvPr id="29" name="Shape 27"/>
+          <p:cNvPr id="28" name="Shape 23"/>
           <p:cNvSpPr/>
           <p:nvPr/>
         </p:nvSpPr>
@@ -2048,7 +1964,7 @@
       </p:sp>
       <p:sp>
         <p:nvSpPr>
-          <p:cNvPr id="30" name="Shape 28"/>
+          <p:cNvPr id="29" name="Shape 24"/>
           <p:cNvSpPr/>
           <p:nvPr/>
         </p:nvSpPr>
@@ -2073,7 +1989,7 @@
       </p:sp>
       <p:sp>
         <p:nvSpPr>
-          <p:cNvPr id="31" name="Text 29"/>
+          <p:cNvPr id="30" name="Text 25"/>
           <p:cNvSpPr/>
           <p:nvPr/>
         </p:nvSpPr>
@@ -2112,7 +2028,7 @@
       </p:sp>
       <p:sp>
         <p:nvSpPr>
-          <p:cNvPr id="32" name="Shape 30"/>
+          <p:cNvPr id="31" name="Shape 26"/>
           <p:cNvSpPr/>
           <p:nvPr/>
         </p:nvSpPr>
@@ -2137,7 +2053,7 @@
       </p:sp>
       <p:sp>
         <p:nvSpPr>
-          <p:cNvPr id="33" name="Text 31"/>
+          <p:cNvPr id="32" name="Text 27"/>
           <p:cNvSpPr/>
           <p:nvPr/>
         </p:nvSpPr>
@@ -2176,7 +2092,7 @@
       </p:sp>
       <p:sp>
         <p:nvSpPr>
-          <p:cNvPr id="34" name="Shape 32"/>
+          <p:cNvPr id="33" name="Shape 28"/>
           <p:cNvSpPr/>
           <p:nvPr/>
         </p:nvSpPr>
@@ -2201,7 +2117,7 @@
       </p:sp>
       <p:sp>
         <p:nvSpPr>
-          <p:cNvPr id="35" name="Text 33"/>
+          <p:cNvPr id="34" name="Text 29"/>
           <p:cNvSpPr/>
           <p:nvPr/>
         </p:nvSpPr>
@@ -2257,7 +2173,7 @@
       </p:sp>
       <p:sp>
         <p:nvSpPr>
-          <p:cNvPr id="36" name="Shape 34"/>
+          <p:cNvPr id="35" name="Shape 30"/>
           <p:cNvSpPr/>
           <p:nvPr/>
         </p:nvSpPr>
@@ -2282,7 +2198,7 @@
       </p:sp>
       <p:sp>
         <p:nvSpPr>
-          <p:cNvPr id="37" name="Text 35"/>
+          <p:cNvPr id="36" name="Text 31"/>
           <p:cNvSpPr/>
           <p:nvPr/>
         </p:nvSpPr>
@@ -2338,7 +2254,7 @@
       </p:sp>
       <p:sp>
         <p:nvSpPr>
-          <p:cNvPr id="38" name="Shape 36"/>
+          <p:cNvPr id="37" name="Shape 32"/>
           <p:cNvSpPr/>
           <p:nvPr/>
         </p:nvSpPr>
@@ -2365,7 +2281,7 @@
       </p:sp>
       <p:sp>
         <p:nvSpPr>
-          <p:cNvPr id="39" name="Text 37"/>
+          <p:cNvPr id="38" name="Text 33"/>
           <p:cNvSpPr/>
           <p:nvPr/>
         </p:nvSpPr>
@@ -2404,7 +2320,7 @@
       </p:sp>
       <p:sp>
         <p:nvSpPr>
-          <p:cNvPr id="40" name="Shape 38"/>
+          <p:cNvPr id="39" name="Shape 34"/>
           <p:cNvSpPr/>
           <p:nvPr/>
         </p:nvSpPr>
@@ -2429,7 +2345,7 @@
       </p:sp>
       <p:sp>
         <p:nvSpPr>
-          <p:cNvPr id="41" name="Text 39"/>
+          <p:cNvPr id="40" name="Text 35"/>
           <p:cNvSpPr/>
           <p:nvPr/>
         </p:nvSpPr>
@@ -2461,7 +2377,7 @@
                 <a:ea typeface="Arial" pitchFamily="34" charset="-122"/>
                 <a:cs typeface="Arial" pitchFamily="34" charset="-120"/>
               </a:rPr>
-              <a:t>Deliver MVP2, 11 capabilities, Aug to Dec 2026</a:t>
+              <a:t>MVP1 delivered, MVP2 build starts Sep 2026</a:t>
             </a:r>
             <a:endParaRPr lang="en-US" sz="850" dirty="0"/>
           </a:p>
@@ -2479,7 +2395,7 @@
                 <a:ea typeface="Arial" pitchFamily="34" charset="-122"/>
                 <a:cs typeface="Arial" pitchFamily="34" charset="-120"/>
               </a:rPr>
-              <a:t>Decide the Second Party onboarding exception</a:t>
+              <a:t>Deliver MVP2, 11 capabilities, complete by Dec 2026</a:t>
             </a:r>
             <a:endParaRPr lang="en-US" sz="850" dirty="0"/>
           </a:p>
@@ -2497,6 +2413,42 @@
                 <a:ea typeface="Arial" pitchFamily="34" charset="-122"/>
                 <a:cs typeface="Arial" pitchFamily="34" charset="-120"/>
               </a:rPr>
+              <a:t>Stand up quality gates: Agent Scoring, EVALS, Red Team testing</a:t>
+            </a:r>
+            <a:endParaRPr lang="en-US" sz="850" dirty="0"/>
+          </a:p>
+          <a:p>
+            <a:pPr marL="152400" indent="-152400">
+              <a:buSzPct val="100000"/>
+              <a:buChar char="•"/>
+            </a:pPr>
+            <a:r>
+              <a:rPr lang="en-US" sz="850" dirty="0">
+                <a:solidFill>
+                  <a:srgbClr val="262626"/>
+                </a:solidFill>
+                <a:latin typeface="Arial" pitchFamily="34" charset="0"/>
+                <a:ea typeface="Arial" pitchFamily="34" charset="-122"/>
+                <a:cs typeface="Arial" pitchFamily="34" charset="-120"/>
+              </a:rPr>
+              <a:t>Measure and report platform value and ROI</a:t>
+            </a:r>
+            <a:endParaRPr lang="en-US" sz="850" dirty="0"/>
+          </a:p>
+          <a:p>
+            <a:pPr marL="152400" indent="-152400">
+              <a:buSzPct val="100000"/>
+              <a:buChar char="•"/>
+            </a:pPr>
+            <a:r>
+              <a:rPr lang="en-US" sz="850" dirty="0">
+                <a:solidFill>
+                  <a:srgbClr val="262626"/>
+                </a:solidFill>
+                <a:latin typeface="Arial" pitchFamily="34" charset="0"/>
+                <a:ea typeface="Arial" pitchFamily="34" charset="-122"/>
+                <a:cs typeface="Arial" pitchFamily="34" charset="-120"/>
+              </a:rPr>
               <a:t>Align MVP2 scope and ownership with Enterprise GenAI</a:t>
             </a:r>
             <a:endParaRPr lang="en-US" sz="850" dirty="0"/>
@@ -2507,6 +2459,42 @@
               <a:buChar char="•"/>
             </a:pPr>
             <a:r>
+              <a:rPr lang="en-US" sz="850" b="1" dirty="0">
+                <a:solidFill>
+                  <a:srgbClr val="262626"/>
+                </a:solidFill>
+                <a:latin typeface="Arial" pitchFamily="34" charset="0"/>
+                <a:ea typeface="Arial" pitchFamily="34" charset="-122"/>
+                <a:cs typeface="Arial" pitchFamily="34" charset="-120"/>
+              </a:rPr>
+              <a:t>Supporting 35+ agents across 4 verticals: ERP, Non-ERP, MLL, Data</a:t>
+            </a:r>
+            <a:endParaRPr lang="en-US" sz="850" dirty="0"/>
+          </a:p>
+          <a:p>
+            <a:pPr marL="152400" indent="-152400">
+              <a:buSzPct val="100000"/>
+              <a:buChar char="•"/>
+            </a:pPr>
+            <a:r>
+              <a:rPr lang="en-US" sz="850" b="1" dirty="0">
+                <a:solidFill>
+                  <a:srgbClr val="262626"/>
+                </a:solidFill>
+                <a:latin typeface="Arial" pitchFamily="34" charset="0"/>
+                <a:ea typeface="Arial" pitchFamily="34" charset="-122"/>
+                <a:cs typeface="Arial" pitchFamily="34" charset="-120"/>
+              </a:rPr>
+              <a:t>Demand: 11 agents in POC / Build</a:t>
+            </a:r>
+            <a:endParaRPr lang="en-US" sz="850" dirty="0"/>
+          </a:p>
+          <a:p>
+            <a:pPr marL="152400" indent="-152400">
+              <a:buSzPct val="100000"/>
+              <a:buChar char="•"/>
+            </a:pPr>
+            <a:r>
               <a:rPr lang="en-US" sz="850" dirty="0">
                 <a:solidFill>
                   <a:srgbClr val="262626"/>
@@ -2515,79 +2503,79 @@
                 <a:ea typeface="Arial" pitchFamily="34" charset="-122"/>
                 <a:cs typeface="Arial" pitchFamily="34" charset="-120"/>
               </a:rPr>
-              <a:t>Onboard the next agent wave through the 4 phase lifecycle</a:t>
+              <a:t>Supporting ongoing programs including:</a:t>
             </a:r>
             <a:endParaRPr lang="en-US" sz="850" dirty="0"/>
           </a:p>
           <a:p>
-            <a:pPr marL="152400" indent="-152400">
-              <a:buSzPct val="100000"/>
-              <a:buChar char="•"/>
-            </a:pPr>
-            <a:r>
-              <a:rPr lang="en-US" sz="850" dirty="0">
-                <a:solidFill>
-                  <a:srgbClr val="262626"/>
-                </a:solidFill>
-                <a:latin typeface="Arial" pitchFamily="34" charset="0"/>
-                <a:ea typeface="Arial" pitchFamily="34" charset="-122"/>
-                <a:cs typeface="Arial" pitchFamily="34" charset="-120"/>
-              </a:rPr>
-              <a:t>Stand up quality gates: Agent Scoring, EVALS, Red Team testing</a:t>
+            <a:pPr lvl="1" marL="304800" indent="-152400">
+              <a:buSzPct val="100000"/>
+              <a:buChar char="•"/>
+            </a:pPr>
+            <a:r>
+              <a:rPr lang="en-US" sz="750" dirty="0">
+                <a:solidFill>
+                  <a:srgbClr val="262626"/>
+                </a:solidFill>
+                <a:latin typeface="Arial" pitchFamily="34" charset="0"/>
+                <a:ea typeface="Arial" pitchFamily="34" charset="-122"/>
+                <a:cs typeface="Arial" pitchFamily="34" charset="-120"/>
+              </a:rPr>
+              <a:t>Solman CR-CO Change &amp; Release Agent</a:t>
             </a:r>
             <a:endParaRPr lang="en-US" sz="850" dirty="0"/>
           </a:p>
           <a:p>
-            <a:pPr marL="152400" indent="-152400">
-              <a:buSzPct val="100000"/>
-              <a:buChar char="•"/>
-            </a:pPr>
-            <a:r>
-              <a:rPr lang="en-US" sz="850" dirty="0">
-                <a:solidFill>
-                  <a:srgbClr val="262626"/>
-                </a:solidFill>
-                <a:latin typeface="Arial" pitchFamily="34" charset="0"/>
-                <a:ea typeface="Arial" pitchFamily="34" charset="-122"/>
-                <a:cs typeface="Arial" pitchFamily="34" charset="-120"/>
-              </a:rPr>
-              <a:t>Finalise the metric framework and dashboard schema</a:t>
+            <a:pPr lvl="1" marL="304800" indent="-152400">
+              <a:buSzPct val="100000"/>
+              <a:buChar char="•"/>
+            </a:pPr>
+            <a:r>
+              <a:rPr lang="en-US" sz="750" dirty="0">
+                <a:solidFill>
+                  <a:srgbClr val="262626"/>
+                </a:solidFill>
+                <a:latin typeface="Arial" pitchFamily="34" charset="0"/>
+                <a:ea typeface="Arial" pitchFamily="34" charset="-122"/>
+                <a:cs typeface="Arial" pitchFamily="34" charset="-120"/>
+              </a:rPr>
+              <a:t>SASA, 21 agents</a:t>
             </a:r>
             <a:endParaRPr lang="en-US" sz="850" dirty="0"/>
           </a:p>
           <a:p>
-            <a:pPr marL="152400" indent="-152400">
-              <a:buSzPct val="100000"/>
-              <a:buChar char="•"/>
-            </a:pPr>
-            <a:r>
-              <a:rPr lang="en-US" sz="850" b="1" dirty="0">
-                <a:solidFill>
-                  <a:srgbClr val="262626"/>
-                </a:solidFill>
-                <a:latin typeface="Arial" pitchFamily="34" charset="0"/>
-                <a:ea typeface="Arial" pitchFamily="34" charset="-122"/>
-                <a:cs typeface="Arial" pitchFamily="34" charset="-120"/>
-              </a:rPr>
-              <a:t>Supporting 35+ agents across 4 verticals: ERP, Non-ERP, MLL, Data</a:t>
+            <a:pPr lvl="1" marL="304800" indent="-152400">
+              <a:buSzPct val="100000"/>
+              <a:buChar char="•"/>
+            </a:pPr>
+            <a:r>
+              <a:rPr lang="en-US" sz="750" dirty="0">
+                <a:solidFill>
+                  <a:srgbClr val="262626"/>
+                </a:solidFill>
+                <a:latin typeface="Arial" pitchFamily="34" charset="0"/>
+                <a:ea typeface="Arial" pitchFamily="34" charset="-122"/>
+                <a:cs typeface="Arial" pitchFamily="34" charset="-120"/>
+              </a:rPr>
+              <a:t>Jira AI Agent</a:t>
             </a:r>
             <a:endParaRPr lang="en-US" sz="850" dirty="0"/>
           </a:p>
           <a:p>
-            <a:pPr marL="152400" indent="-152400">
-              <a:buSzPct val="100000"/>
-              <a:buChar char="•"/>
-            </a:pPr>
-            <a:r>
-              <a:rPr lang="en-US" sz="850" dirty="0">
-                <a:solidFill>
-                  <a:srgbClr val="262626"/>
-                </a:solidFill>
-                <a:latin typeface="Arial" pitchFamily="34" charset="0"/>
-                <a:ea typeface="Arial" pitchFamily="34" charset="-122"/>
-                <a:cs typeface="Arial" pitchFamily="34" charset="-120"/>
-              </a:rPr>
-              <a:t>Supporting ongoing programs including:</a:t>
+            <a:pPr lvl="1" marL="304800" indent="-152400">
+              <a:buSzPct val="100000"/>
+              <a:buChar char="•"/>
+            </a:pPr>
+            <a:r>
+              <a:rPr lang="en-US" sz="750" dirty="0">
+                <a:solidFill>
+                  <a:srgbClr val="262626"/>
+                </a:solidFill>
+                <a:latin typeface="Arial" pitchFamily="34" charset="0"/>
+                <a:ea typeface="Arial" pitchFamily="34" charset="-122"/>
+                <a:cs typeface="Arial" pitchFamily="34" charset="-120"/>
+              </a:rPr>
+              <a:t>AI SDLC Agent, AGT-001</a:t>
             </a:r>
             <a:endParaRPr lang="en-US" sz="850" dirty="0"/>
           </a:p>
@@ -2605,7 +2593,7 @@
                 <a:ea typeface="Arial" pitchFamily="34" charset="-122"/>
                 <a:cs typeface="Arial" pitchFamily="34" charset="-120"/>
               </a:rPr>
-              <a:t>CR-CO Change &amp; Release Agent</a:t>
+              <a:t>Test Automation family, AGT-016 to AGT-021</a:t>
             </a:r>
             <a:endParaRPr lang="en-US" sz="850" dirty="0"/>
           </a:p>
@@ -2623,105 +2611,15 @@
                 <a:ea typeface="Arial" pitchFamily="34" charset="-122"/>
                 <a:cs typeface="Arial" pitchFamily="34" charset="-120"/>
               </a:rPr>
-              <a:t>SASA, 21 agents</a:t>
+              <a:t>BTP Integration agents, AGT-013 to AGT-015</a:t>
             </a:r>
             <a:endParaRPr lang="en-US" sz="850" dirty="0"/>
           </a:p>
-          <a:p>
-            <a:pPr lvl="1" marL="304800" indent="-152400">
-              <a:buSzPct val="100000"/>
-              <a:buChar char="•"/>
-            </a:pPr>
-            <a:r>
-              <a:rPr lang="en-US" sz="750" dirty="0">
-                <a:solidFill>
-                  <a:srgbClr val="262626"/>
-                </a:solidFill>
-                <a:latin typeface="Arial" pitchFamily="34" charset="0"/>
-                <a:ea typeface="Arial" pitchFamily="34" charset="-122"/>
-                <a:cs typeface="Arial" pitchFamily="34" charset="-120"/>
-              </a:rPr>
-              <a:t>Jira AI Agent</a:t>
-            </a:r>
-            <a:endParaRPr lang="en-US" sz="850" dirty="0"/>
-          </a:p>
-          <a:p>
-            <a:pPr lvl="1" marL="304800" indent="-152400">
-              <a:buSzPct val="100000"/>
-              <a:buChar char="•"/>
-            </a:pPr>
-            <a:r>
-              <a:rPr lang="en-US" sz="750" dirty="0">
-                <a:solidFill>
-                  <a:srgbClr val="262626"/>
-                </a:solidFill>
-                <a:latin typeface="Arial" pitchFamily="34" charset="0"/>
-                <a:ea typeface="Arial" pitchFamily="34" charset="-122"/>
-                <a:cs typeface="Arial" pitchFamily="34" charset="-120"/>
-              </a:rPr>
-              <a:t>AI SDLC Agent, AGT-001</a:t>
-            </a:r>
-            <a:endParaRPr lang="en-US" sz="850" dirty="0"/>
-          </a:p>
-          <a:p>
-            <a:pPr lvl="1" marL="304800" indent="-152400">
-              <a:buSzPct val="100000"/>
-              <a:buChar char="•"/>
-            </a:pPr>
-            <a:r>
-              <a:rPr lang="en-US" sz="750" dirty="0">
-                <a:solidFill>
-                  <a:srgbClr val="262626"/>
-                </a:solidFill>
-                <a:latin typeface="Arial" pitchFamily="34" charset="0"/>
-                <a:ea typeface="Arial" pitchFamily="34" charset="-122"/>
-                <a:cs typeface="Arial" pitchFamily="34" charset="-120"/>
-              </a:rPr>
-              <a:t>Test Automation family, AGT-016 to AGT-021</a:t>
-            </a:r>
-            <a:endParaRPr lang="en-US" sz="850" dirty="0"/>
-          </a:p>
-          <a:p>
-            <a:pPr lvl="1" marL="304800" indent="-152400">
-              <a:buSzPct val="100000"/>
-              <a:buChar char="•"/>
-            </a:pPr>
-            <a:r>
-              <a:rPr lang="en-US" sz="750" dirty="0">
-                <a:solidFill>
-                  <a:srgbClr val="262626"/>
-                </a:solidFill>
-                <a:latin typeface="Arial" pitchFamily="34" charset="0"/>
-                <a:ea typeface="Arial" pitchFamily="34" charset="-122"/>
-                <a:cs typeface="Arial" pitchFamily="34" charset="-120"/>
-              </a:rPr>
-              <a:t>BTP Integration agents, AGT-013 to AGT-015</a:t>
-            </a:r>
-            <a:endParaRPr lang="en-US" sz="850" dirty="0"/>
-          </a:p>
-          <a:p>
-            <a:pPr lvl="1" marL="304800" indent="-152400">
-              <a:buSzPct val="100000"/>
-              <a:buChar char="•"/>
-            </a:pPr>
-            <a:r>
-              <a:rPr lang="en-US" sz="800" dirty="0">
-                <a:solidFill>
-                  <a:srgbClr val="262626"/>
-                </a:solidFill>
-                <a:latin typeface="Arial" pitchFamily="34" charset="0"/>
-                <a:ea typeface="Arial" pitchFamily="34" charset="-122"/>
-                <a:cs typeface="Arial" pitchFamily="34" charset="-120"/>
-              </a:rPr>
-              <a:t>Enterprise Registry Integration</a:t>
-            </a:r>
-            <a:endParaRPr lang="en-US" sz="850" dirty="0"/>
-          </a:p>
-        </p:txBody>
-      </p:sp>
-      <p:sp>
-        <p:nvSpPr>
-          <p:cNvPr id="42" name="Shape 40"/>
+        </p:txBody>
+      </p:sp>
+      <p:sp>
+        <p:nvSpPr>
+          <p:cNvPr id="41" name="Shape 36"/>
           <p:cNvSpPr/>
           <p:nvPr/>
         </p:nvSpPr>
@@ -2748,7 +2646,7 @@
       </p:sp>
       <p:sp>
         <p:nvSpPr>
-          <p:cNvPr id="43" name="Text 41"/>
+          <p:cNvPr id="42" name="Text 37"/>
           <p:cNvSpPr/>
           <p:nvPr/>
         </p:nvSpPr>
@@ -2787,7 +2685,7 @@
       </p:sp>
       <p:sp>
         <p:nvSpPr>
-          <p:cNvPr id="44" name="Shape 42"/>
+          <p:cNvPr id="43" name="Shape 38"/>
           <p:cNvSpPr/>
           <p:nvPr/>
         </p:nvSpPr>
@@ -2812,7 +2710,7 @@
       </p:sp>
       <p:sp>
         <p:nvSpPr>
-          <p:cNvPr id="45" name="Text 43"/>
+          <p:cNvPr id="44" name="Text 39"/>
           <p:cNvSpPr/>
           <p:nvPr/>
         </p:nvSpPr>
@@ -2861,7 +2759,7 @@
                 <a:ea typeface="Arial" pitchFamily="34" charset="-122"/>
                 <a:cs typeface="Arial" pitchFamily="34" charset="-120"/>
               </a:rPr>
-              <a:t>23 agents running in production</a:t>
+              <a:t>23 AI agents live in production</a:t>
             </a:r>
             <a:endParaRPr lang="en-US" sz="800" dirty="0"/>
           </a:p>
@@ -2879,7 +2777,7 @@
                 <a:ea typeface="Arial" pitchFamily="34" charset="-122"/>
                 <a:cs typeface="Arial" pitchFamily="34" charset="-120"/>
               </a:rPr>
-              <a:t>4 MVP1 surfaces live: Chat, Setup, Monitoring, Dashboard</a:t>
+              <a:t>4 verticals covered: ERP, Non-ERP, MLL, Data</a:t>
             </a:r>
             <a:endParaRPr lang="en-US" sz="800" dirty="0"/>
           </a:p>
@@ -2897,7 +2795,7 @@
                 <a:ea typeface="Arial" pitchFamily="34" charset="-122"/>
                 <a:cs typeface="Arial" pitchFamily="34" charset="-120"/>
               </a:rPr>
-              <a:t>3 SDLC environments, DEV, QA and PROD</a:t>
+              <a:t>MVP1 delivered</a:t>
             </a:r>
             <a:endParaRPr lang="en-US" sz="800" dirty="0"/>
           </a:p>
@@ -2914,7 +2812,7 @@
                 <a:ea typeface="Arial" pitchFamily="34" charset="-122"/>
                 <a:cs typeface="Arial" pitchFamily="34" charset="-120"/>
               </a:rPr>
-              <a:t>Operational Excellence</a:t>
+              <a:t>Governance &amp; Assurance</a:t>
             </a:r>
             <a:endParaRPr lang="en-US" sz="800" dirty="0"/>
           </a:p>
@@ -2932,7 +2830,7 @@
                 <a:ea typeface="Arial" pitchFamily="34" charset="-122"/>
                 <a:cs typeface="Arial" pitchFamily="34" charset="-120"/>
               </a:rPr>
-              <a:t>GxP low risk designation, validated approach</a:t>
+              <a:t>Agent onboarding governed</a:t>
             </a:r>
             <a:endParaRPr lang="en-US" sz="800" dirty="0"/>
           </a:p>
@@ -2950,25 +2848,7 @@
                 <a:ea typeface="Arial" pitchFamily="34" charset="-122"/>
                 <a:cs typeface="Arial" pitchFamily="34" charset="-120"/>
               </a:rPr>
-              <a:t>4 phase lifecycle and 2 CR promotion model published</a:t>
-            </a:r>
-            <a:endParaRPr lang="en-US" sz="800" dirty="0"/>
-          </a:p>
-          <a:p>
-            <a:pPr lvl="1" marL="304800" indent="-152400">
-              <a:buSzPct val="100000"/>
-              <a:buChar char="•"/>
-            </a:pPr>
-            <a:r>
-              <a:rPr lang="en-US" sz="750" dirty="0">
-                <a:solidFill>
-                  <a:srgbClr val="262626"/>
-                </a:solidFill>
-                <a:latin typeface="Arial" pitchFamily="34" charset="0"/>
-                <a:ea typeface="Arial" pitchFamily="34" charset="-122"/>
-                <a:cs typeface="Arial" pitchFamily="34" charset="-120"/>
-              </a:rPr>
-              <a:t>71 question technical intake set published</a:t>
+              <a:t>Dashboard metric catalog drafted, 77 candidate metrics</a:t>
             </a:r>
             <a:endParaRPr lang="en-US" sz="800" dirty="0"/>
           </a:p>
@@ -2985,7 +2865,7 @@
                 <a:ea typeface="Arial" pitchFamily="34" charset="-122"/>
                 <a:cs typeface="Arial" pitchFamily="34" charset="-120"/>
               </a:rPr>
-              <a:t>Innovation</a:t>
+              <a:t>Enterprise Alignment</a:t>
             </a:r>
             <a:endParaRPr lang="en-US" sz="800" dirty="0"/>
           </a:p>
@@ -3003,7 +2883,7 @@
                 <a:ea typeface="Arial" pitchFamily="34" charset="-122"/>
                 <a:cs typeface="Arial" pitchFamily="34" charset="-120"/>
               </a:rPr>
-              <a:t>Temporal assessment and deployment architecture complete</a:t>
+              <a:t>MVP2 scope aligned with Enterprise GenAI</a:t>
             </a:r>
             <a:endParaRPr lang="en-US" sz="800" dirty="0"/>
           </a:p>
@@ -3021,7 +2901,7 @@
                 <a:ea typeface="Arial" pitchFamily="34" charset="-122"/>
                 <a:cs typeface="Arial" pitchFamily="34" charset="-120"/>
               </a:rPr>
-              <a:t>77 metric catalog drafted across 5 categories</a:t>
+              <a:t>Ownership agreed across 11 capabilities</a:t>
             </a:r>
             <a:endParaRPr lang="en-US" sz="800" dirty="0"/>
           </a:p>
@@ -3039,7 +2919,7 @@
                 <a:ea typeface="Arial" pitchFamily="34" charset="-122"/>
                 <a:cs typeface="Arial" pitchFamily="34" charset="-120"/>
               </a:rPr>
-              <a:t>8 block telemetry payload standardised</a:t>
+              <a:t>Temporal assessment and financial summary delivered</a:t>
             </a:r>
             <a:endParaRPr lang="en-US" sz="800" dirty="0"/>
           </a:p>
@@ -3047,7 +2927,7 @@
       </p:sp>
       <p:sp>
         <p:nvSpPr>
-          <p:cNvPr id="46" name="Shape 44"/>
+          <p:cNvPr id="45" name="Shape 40"/>
           <p:cNvSpPr/>
           <p:nvPr/>
         </p:nvSpPr>
@@ -3074,7 +2954,7 @@
       </p:sp>
       <p:sp>
         <p:nvSpPr>
-          <p:cNvPr id="47" name="Text 45"/>
+          <p:cNvPr id="46" name="Text 41"/>
           <p:cNvSpPr/>
           <p:nvPr/>
         </p:nvSpPr>
@@ -3130,7 +3010,7 @@
       </p:sp>
       <p:sp>
         <p:nvSpPr>
-          <p:cNvPr id="48" name="Shape 46"/>
+          <p:cNvPr id="47" name="Shape 42"/>
           <p:cNvSpPr/>
           <p:nvPr/>
         </p:nvSpPr>
@@ -3155,7 +3035,7 @@
       </p:sp>
       <p:sp>
         <p:nvSpPr>
-          <p:cNvPr id="49" name="Text 47"/>
+          <p:cNvPr id="48" name="Text 43"/>
           <p:cNvSpPr/>
           <p:nvPr/>
         </p:nvSpPr>
@@ -3194,7 +3074,7 @@
       </p:sp>
       <p:sp>
         <p:nvSpPr>
-          <p:cNvPr id="50" name="Shape 48"/>
+          <p:cNvPr id="49" name="Shape 44"/>
           <p:cNvSpPr/>
           <p:nvPr/>
         </p:nvSpPr>
@@ -3221,7 +3101,7 @@
       </p:sp>
       <p:sp>
         <p:nvSpPr>
-          <p:cNvPr id="51" name="Text 49"/>
+          <p:cNvPr id="50" name="Text 45"/>
           <p:cNvSpPr/>
           <p:nvPr/>
         </p:nvSpPr>
@@ -3260,7 +3140,7 @@
       </p:sp>
       <p:sp>
         <p:nvSpPr>
-          <p:cNvPr id="52" name="Shape 50"/>
+          <p:cNvPr id="51" name="Shape 46"/>
           <p:cNvSpPr/>
           <p:nvPr/>
         </p:nvSpPr>
@@ -3285,7 +3165,7 @@
       </p:sp>
       <p:sp>
         <p:nvSpPr>
-          <p:cNvPr id="53" name="Text 51"/>
+          <p:cNvPr id="52" name="Text 47"/>
           <p:cNvSpPr/>
           <p:nvPr/>
         </p:nvSpPr>
@@ -3324,14 +3204,14 @@
       </p:sp>
       <p:sp>
         <p:nvSpPr>
-          <p:cNvPr id="54" name="Text 52"/>
+          <p:cNvPr id="53" name="Text 48"/>
           <p:cNvSpPr/>
           <p:nvPr/>
         </p:nvSpPr>
         <p:spPr>
           <a:xfrm>
             <a:off x="5532120" y="5669280"/>
-            <a:ext cx="2834640" cy="896112"/>
+            <a:ext cx="2834640" cy="658368"/>
           </a:xfrm>
           <a:prstGeom prst="rect">
             <a:avLst/>
@@ -3356,7 +3236,7 @@
                 <a:ea typeface="Arial" pitchFamily="34" charset="-122"/>
                 <a:cs typeface="Arial" pitchFamily="34" charset="-120"/>
               </a:rPr>
-              <a:t>23 agents live, quality gates in MVP2</a:t>
+              <a:t>Agent demand growth across 4 verticals</a:t>
             </a:r>
             <a:endParaRPr lang="en-US" sz="900" dirty="0"/>
           </a:p>
@@ -3374,7 +3254,7 @@
                 <a:ea typeface="Arial" pitchFamily="34" charset="-122"/>
                 <a:cs typeface="Arial" pitchFamily="34" charset="-120"/>
               </a:rPr>
-              <a:t>Quality metrics blocked on ledger schema</a:t>
+              <a:t>6 of 11 MVP2 features Enterprise owned</a:t>
             </a:r>
             <a:endParaRPr lang="en-US" sz="900" dirty="0"/>
           </a:p>
@@ -3392,7 +3272,7 @@
                 <a:ea typeface="Arial" pitchFamily="34" charset="-122"/>
                 <a:cs typeface="Arial" pitchFamily="34" charset="-120"/>
               </a:rPr>
-              <a:t>6 of 11 features Enterprise owned</a:t>
+              <a:t>GxP assurance at agent scale</a:t>
             </a:r>
             <a:endParaRPr lang="en-US" sz="900" dirty="0"/>
           </a:p>
@@ -3410,7 +3290,7 @@
                 <a:ea typeface="Arial" pitchFamily="34" charset="-122"/>
                 <a:cs typeface="Arial" pitchFamily="34" charset="-120"/>
               </a:rPr>
-              <a:t>Contested capability ownership</a:t>
+              <a:t>AI security tooling decision pending</a:t>
             </a:r>
             <a:endParaRPr lang="en-US" sz="900" dirty="0"/>
           </a:p>
@@ -3418,7 +3298,7 @@
       </p:sp>
       <p:sp>
         <p:nvSpPr>
-          <p:cNvPr id="55" name="Text 53"/>
+          <p:cNvPr id="54" name="Text 49"/>
           <p:cNvSpPr/>
           <p:nvPr/>
         </p:nvSpPr>
@@ -3457,14 +3337,14 @@
       </p:sp>
       <p:sp>
         <p:nvSpPr>
-          <p:cNvPr id="56" name="Text 54"/>
+          <p:cNvPr id="55" name="Text 50"/>
           <p:cNvSpPr/>
           <p:nvPr/>
         </p:nvSpPr>
         <p:spPr>
           <a:xfrm>
             <a:off x="8705088" y="5669280"/>
-            <a:ext cx="3017520" cy="896112"/>
+            <a:ext cx="3017520" cy="658368"/>
           </a:xfrm>
           <a:prstGeom prst="rect">
             <a:avLst/>
@@ -3525,14 +3405,49 @@
                 <a:ea typeface="Arial" pitchFamily="34" charset="-122"/>
                 <a:cs typeface="Arial" pitchFamily="34" charset="-120"/>
               </a:rPr>
-              <a:t>Enterprise registry reuse</a:t>
+              <a:t>Generative UI and voice assistance</a:t>
             </a:r>
             <a:endParaRPr lang="en-US" sz="900" dirty="0"/>
           </a:p>
-          <a:p>
-            <a:pPr marL="152400" indent="-152400">
-              <a:buSzPct val="100000"/>
-              <a:buChar char="•"/>
+        </p:txBody>
+      </p:sp>
+      <p:sp>
+        <p:nvSpPr>
+          <p:cNvPr id="56" name="Text 51"/>
+          <p:cNvSpPr/>
+          <p:nvPr/>
+        </p:nvSpPr>
+        <p:spPr>
+          <a:xfrm>
+            <a:off x="5376672" y="6355080"/>
+            <a:ext cx="6355080" cy="237744"/>
+          </a:xfrm>
+          <a:prstGeom prst="rect">
+            <a:avLst/>
+          </a:prstGeom>
+          <a:noFill/>
+          <a:ln/>
+        </p:spPr>
+        <p:txBody>
+          <a:bodyPr wrap="square" lIns="0" tIns="0" rIns="0" bIns="0" rtlCol="0" anchor="ctr"/>
+          <a:lstStyle/>
+          <a:p>
+            <a:pPr indent="0" marL="0">
+              <a:buNone/>
+            </a:pPr>
+            <a:r>
+              <a:rPr lang="en-US" sz="900" b="1" dirty="0">
+                <a:solidFill>
+                  <a:srgbClr val="1B365D"/>
+                </a:solidFill>
+                <a:latin typeface="Arial" pitchFamily="34" charset="0"/>
+                <a:ea typeface="Arial" pitchFamily="34" charset="-122"/>
+                <a:cs typeface="Arial" pitchFamily="34" charset="-120"/>
+              </a:rPr>
+              <a:t>How we are addressing:  </a:t>
+            </a:r>
+            <a:pPr indent="0" marL="0">
+              <a:buNone/>
             </a:pPr>
             <a:r>
               <a:rPr lang="en-US" sz="900" dirty="0">
@@ -3543,7 +3458,7 @@
                 <a:ea typeface="Arial" pitchFamily="34" charset="-122"/>
                 <a:cs typeface="Arial" pitchFamily="34" charset="-120"/>
               </a:rPr>
-              <a:t>Value realization dashboards</a:t>
+              <a:t>SDLC-owned quality gates land in MVP2, every capability has a named owner, and delivery is tracked on one timeline jointly with Enterprise.</a:t>
             </a:r>
             <a:endParaRPr lang="en-US" sz="900" dirty="0"/>
           </a:p>
@@ -3551,7 +3466,7 @@
       </p:sp>
       <p:sp>
         <p:nvSpPr>
-          <p:cNvPr id="57" name="Text 55"/>
+          <p:cNvPr id="57" name="Text 52"/>
           <p:cNvSpPr/>
           <p:nvPr/>
         </p:nvSpPr>
@@ -3685,7 +3600,7 @@
                 <a:ea typeface="Arial" pitchFamily="34" charset="-122"/>
                 <a:cs typeface="Arial" pitchFamily="34" charset="-120"/>
               </a:rPr>
-              <a:t>MVP2 release plan, cross service dependencies and 2027 direction</a:t>
+              <a:t>MVP2 release plan, dependencies, agent portfolio and capability detail</a:t>
             </a:r>
             <a:endParaRPr lang="en-US" sz="1300" dirty="0"/>
           </a:p>
@@ -3948,7 +3863,7 @@
                 <a:ea typeface="Arial" pitchFamily="34" charset="-122"/>
                 <a:cs typeface="Arial" pitchFamily="34" charset="-120"/>
               </a:rPr>
-              <a:t>Milestone: Telemetry &amp; FinOps live</a:t>
+              <a:t>Milestone: Baseline telemetry live</a:t>
             </a:r>
             <a:endParaRPr lang="en-US" sz="950" dirty="0"/>
           </a:p>
@@ -4317,7 +4232,7 @@
                 <a:ea typeface="Arial" pitchFamily="34" charset="-122"/>
                 <a:cs typeface="Arial" pitchFamily="34" charset="-120"/>
               </a:rPr>
-              <a:t>XENA CI/CD pipelines, ECR production path and scaffolding</a:t>
+              <a:t>XENA CI/CD pipelines and account scaffolding</a:t>
             </a:r>
             <a:endParaRPr lang="en-US" sz="950" dirty="0"/>
           </a:p>
@@ -4353,7 +4268,7 @@
         <p:spPr>
           <a:xfrm>
             <a:off x="274320" y="3794760"/>
-            <a:ext cx="2743200" cy="365760"/>
+            <a:ext cx="2377440" cy="365760"/>
           </a:xfrm>
           <a:prstGeom prst="roundRect">
             <a:avLst>
@@ -4380,7 +4295,7 @@
         <p:spPr>
           <a:xfrm>
             <a:off x="274320" y="3794760"/>
-            <a:ext cx="2743200" cy="365760"/>
+            <a:ext cx="2377440" cy="365760"/>
           </a:xfrm>
           <a:prstGeom prst="rect">
             <a:avLst/>
@@ -4404,7 +4319,7 @@
                 <a:ea typeface="Arial" pitchFamily="34" charset="-122"/>
                 <a:cs typeface="Arial" pitchFamily="34" charset="-120"/>
               </a:rPr>
-              <a:t>2027 High-Level Forecast</a:t>
+              <a:t>Agent Portfolio</a:t>
             </a:r>
             <a:endParaRPr lang="en-US" sz="1200" dirty="0"/>
           </a:p>
@@ -4419,7 +4334,7 @@
         <p:spPr>
           <a:xfrm>
             <a:off x="274320" y="4206240"/>
-            <a:ext cx="11612880" cy="2331720"/>
+            <a:ext cx="5532120" cy="2331720"/>
           </a:xfrm>
           <a:prstGeom prst="rect">
             <a:avLst/>
@@ -4437,14 +4352,41 @@
       </p:sp>
       <p:sp>
         <p:nvSpPr>
-          <p:cNvPr id="20" name="Text 18"/>
-          <p:cNvSpPr/>
-          <p:nvPr/>
-        </p:nvSpPr>
-        <p:spPr>
-          <a:xfrm>
-            <a:off x="502920" y="4343400"/>
-            <a:ext cx="11155680" cy="274320"/>
+          <p:cNvPr id="20" name="Shape 18"/>
+          <p:cNvSpPr/>
+          <p:nvPr/>
+        </p:nvSpPr>
+        <p:spPr>
+          <a:xfrm>
+            <a:off x="411480" y="4343400"/>
+            <a:ext cx="1207008" cy="420624"/>
+          </a:xfrm>
+          <a:prstGeom prst="roundRect">
+            <a:avLst>
+              <a:gd name="adj" fmla="val 21739"/>
+            </a:avLst>
+          </a:prstGeom>
+          <a:solidFill>
+            <a:srgbClr val="F2F5FA"/>
+          </a:solidFill>
+          <a:ln w="12700">
+            <a:solidFill>
+              <a:srgbClr val="D0D0D0"/>
+            </a:solidFill>
+            <a:prstDash val="solid"/>
+          </a:ln>
+        </p:spPr>
+      </p:sp>
+      <p:sp>
+        <p:nvSpPr>
+          <p:cNvPr id="21" name="Text 19"/>
+          <p:cNvSpPr/>
+          <p:nvPr/>
+        </p:nvSpPr>
+        <p:spPr>
+          <a:xfrm>
+            <a:off x="411480" y="4370832"/>
+            <a:ext cx="1207008" cy="219456"/>
           </a:xfrm>
           <a:prstGeom prst="rect">
             <a:avLst/>
@@ -4456,34 +4398,515 @@
           <a:bodyPr wrap="square" lIns="0" tIns="0" rIns="0" bIns="0" rtlCol="0" anchor="ctr"/>
           <a:lstStyle/>
           <a:p>
-            <a:pPr indent="0" marL="0">
+            <a:pPr algn="ctr" indent="0" marL="0">
               <a:buNone/>
             </a:pPr>
             <a:r>
-              <a:rPr lang="en-US" sz="1200" i="1" dirty="0">
-                <a:solidFill>
-                  <a:srgbClr val="262626"/>
-                </a:solidFill>
-                <a:latin typeface="Arial" pitchFamily="34" charset="0"/>
-                <a:ea typeface="Arial" pitchFamily="34" charset="-122"/>
-                <a:cs typeface="Arial" pitchFamily="34" charset="-120"/>
-              </a:rPr>
-              <a:t>Scale the AI SDLC Platform from a First Party agent host into the enterprise's end to end, GxP ready AI SDLC layer.</a:t>
-            </a:r>
-            <a:endParaRPr lang="en-US" sz="1200" dirty="0"/>
-          </a:p>
-        </p:txBody>
-      </p:sp>
-      <p:sp>
-        <p:nvSpPr>
-          <p:cNvPr id="21" name="Shape 19"/>
-          <p:cNvSpPr/>
-          <p:nvPr/>
-        </p:nvSpPr>
-        <p:spPr>
-          <a:xfrm>
-            <a:off x="548640" y="4800600"/>
-            <a:ext cx="2377440" cy="274320"/>
+              <a:rPr lang="en-US" sz="1400" b="1" dirty="0">
+                <a:solidFill>
+                  <a:srgbClr val="1B365D"/>
+                </a:solidFill>
+                <a:latin typeface="Arial" pitchFamily="34" charset="0"/>
+                <a:ea typeface="Arial" pitchFamily="34" charset="-122"/>
+                <a:cs typeface="Arial" pitchFamily="34" charset="-120"/>
+              </a:rPr>
+              <a:t>23</a:t>
+            </a:r>
+            <a:endParaRPr lang="en-US" sz="1400" dirty="0"/>
+          </a:p>
+        </p:txBody>
+      </p:sp>
+      <p:sp>
+        <p:nvSpPr>
+          <p:cNvPr id="22" name="Text 20"/>
+          <p:cNvSpPr/>
+          <p:nvPr/>
+        </p:nvSpPr>
+        <p:spPr>
+          <a:xfrm>
+            <a:off x="411480" y="4581144"/>
+            <a:ext cx="1207008" cy="146304"/>
+          </a:xfrm>
+          <a:prstGeom prst="rect">
+            <a:avLst/>
+          </a:prstGeom>
+          <a:noFill/>
+          <a:ln/>
+        </p:spPr>
+        <p:txBody>
+          <a:bodyPr wrap="square" lIns="0" tIns="0" rIns="0" bIns="0" rtlCol="0" anchor="ctr"/>
+          <a:lstStyle/>
+          <a:p>
+            <a:pPr algn="ctr" indent="0" marL="0">
+              <a:buNone/>
+            </a:pPr>
+            <a:r>
+              <a:rPr lang="en-US" sz="700" dirty="0">
+                <a:solidFill>
+                  <a:srgbClr val="5A5A5A"/>
+                </a:solidFill>
+                <a:latin typeface="Arial" pitchFamily="34" charset="0"/>
+                <a:ea typeface="Arial" pitchFamily="34" charset="-122"/>
+                <a:cs typeface="Arial" pitchFamily="34" charset="-120"/>
+              </a:rPr>
+              <a:t>Scale / Live</a:t>
+            </a:r>
+            <a:endParaRPr lang="en-US" sz="700" dirty="0"/>
+          </a:p>
+        </p:txBody>
+      </p:sp>
+      <p:sp>
+        <p:nvSpPr>
+          <p:cNvPr id="23" name="Shape 21"/>
+          <p:cNvSpPr/>
+          <p:nvPr/>
+        </p:nvSpPr>
+        <p:spPr>
+          <a:xfrm>
+            <a:off x="1709928" y="4343400"/>
+            <a:ext cx="1207008" cy="420624"/>
+          </a:xfrm>
+          <a:prstGeom prst="roundRect">
+            <a:avLst>
+              <a:gd name="adj" fmla="val 21739"/>
+            </a:avLst>
+          </a:prstGeom>
+          <a:solidFill>
+            <a:srgbClr val="F2F5FA"/>
+          </a:solidFill>
+          <a:ln w="12700">
+            <a:solidFill>
+              <a:srgbClr val="D0D0D0"/>
+            </a:solidFill>
+            <a:prstDash val="solid"/>
+          </a:ln>
+        </p:spPr>
+      </p:sp>
+      <p:sp>
+        <p:nvSpPr>
+          <p:cNvPr id="24" name="Text 22"/>
+          <p:cNvSpPr/>
+          <p:nvPr/>
+        </p:nvSpPr>
+        <p:spPr>
+          <a:xfrm>
+            <a:off x="1709928" y="4370832"/>
+            <a:ext cx="1207008" cy="219456"/>
+          </a:xfrm>
+          <a:prstGeom prst="rect">
+            <a:avLst/>
+          </a:prstGeom>
+          <a:noFill/>
+          <a:ln/>
+        </p:spPr>
+        <p:txBody>
+          <a:bodyPr wrap="square" lIns="0" tIns="0" rIns="0" bIns="0" rtlCol="0" anchor="ctr"/>
+          <a:lstStyle/>
+          <a:p>
+            <a:pPr algn="ctr" indent="0" marL="0">
+              <a:buNone/>
+            </a:pPr>
+            <a:r>
+              <a:rPr lang="en-US" sz="1400" b="1" dirty="0">
+                <a:solidFill>
+                  <a:srgbClr val="1B365D"/>
+                </a:solidFill>
+                <a:latin typeface="Arial" pitchFamily="34" charset="0"/>
+                <a:ea typeface="Arial" pitchFamily="34" charset="-122"/>
+                <a:cs typeface="Arial" pitchFamily="34" charset="-120"/>
+              </a:rPr>
+              <a:t>1</a:t>
+            </a:r>
+            <a:endParaRPr lang="en-US" sz="1400" dirty="0"/>
+          </a:p>
+        </p:txBody>
+      </p:sp>
+      <p:sp>
+        <p:nvSpPr>
+          <p:cNvPr id="25" name="Text 23"/>
+          <p:cNvSpPr/>
+          <p:nvPr/>
+        </p:nvSpPr>
+        <p:spPr>
+          <a:xfrm>
+            <a:off x="1709928" y="4581144"/>
+            <a:ext cx="1207008" cy="146304"/>
+          </a:xfrm>
+          <a:prstGeom prst="rect">
+            <a:avLst/>
+          </a:prstGeom>
+          <a:noFill/>
+          <a:ln/>
+        </p:spPr>
+        <p:txBody>
+          <a:bodyPr wrap="square" lIns="0" tIns="0" rIns="0" bIns="0" rtlCol="0" anchor="ctr"/>
+          <a:lstStyle/>
+          <a:p>
+            <a:pPr algn="ctr" indent="0" marL="0">
+              <a:buNone/>
+            </a:pPr>
+            <a:r>
+              <a:rPr lang="en-US" sz="700" dirty="0">
+                <a:solidFill>
+                  <a:srgbClr val="5A5A5A"/>
+                </a:solidFill>
+                <a:latin typeface="Arial" pitchFamily="34" charset="0"/>
+                <a:ea typeface="Arial" pitchFamily="34" charset="-122"/>
+                <a:cs typeface="Arial" pitchFamily="34" charset="-120"/>
+              </a:rPr>
+              <a:t>Pilot / Expand</a:t>
+            </a:r>
+            <a:endParaRPr lang="en-US" sz="700" dirty="0"/>
+          </a:p>
+        </p:txBody>
+      </p:sp>
+      <p:sp>
+        <p:nvSpPr>
+          <p:cNvPr id="26" name="Shape 24"/>
+          <p:cNvSpPr/>
+          <p:nvPr/>
+        </p:nvSpPr>
+        <p:spPr>
+          <a:xfrm>
+            <a:off x="3008376" y="4343400"/>
+            <a:ext cx="1207008" cy="420624"/>
+          </a:xfrm>
+          <a:prstGeom prst="roundRect">
+            <a:avLst>
+              <a:gd name="adj" fmla="val 21739"/>
+            </a:avLst>
+          </a:prstGeom>
+          <a:solidFill>
+            <a:srgbClr val="F2F5FA"/>
+          </a:solidFill>
+          <a:ln w="12700">
+            <a:solidFill>
+              <a:srgbClr val="D0D0D0"/>
+            </a:solidFill>
+            <a:prstDash val="solid"/>
+          </a:ln>
+        </p:spPr>
+      </p:sp>
+      <p:sp>
+        <p:nvSpPr>
+          <p:cNvPr id="27" name="Text 25"/>
+          <p:cNvSpPr/>
+          <p:nvPr/>
+        </p:nvSpPr>
+        <p:spPr>
+          <a:xfrm>
+            <a:off x="3008376" y="4370832"/>
+            <a:ext cx="1207008" cy="219456"/>
+          </a:xfrm>
+          <a:prstGeom prst="rect">
+            <a:avLst/>
+          </a:prstGeom>
+          <a:noFill/>
+          <a:ln/>
+        </p:spPr>
+        <p:txBody>
+          <a:bodyPr wrap="square" lIns="0" tIns="0" rIns="0" bIns="0" rtlCol="0" anchor="ctr"/>
+          <a:lstStyle/>
+          <a:p>
+            <a:pPr algn="ctr" indent="0" marL="0">
+              <a:buNone/>
+            </a:pPr>
+            <a:r>
+              <a:rPr lang="en-US" sz="1400" b="1" dirty="0">
+                <a:solidFill>
+                  <a:srgbClr val="1B365D"/>
+                </a:solidFill>
+                <a:latin typeface="Arial" pitchFamily="34" charset="0"/>
+                <a:ea typeface="Arial" pitchFamily="34" charset="-122"/>
+                <a:cs typeface="Arial" pitchFamily="34" charset="-120"/>
+              </a:rPr>
+              <a:t>11</a:t>
+            </a:r>
+            <a:endParaRPr lang="en-US" sz="1400" dirty="0"/>
+          </a:p>
+        </p:txBody>
+      </p:sp>
+      <p:sp>
+        <p:nvSpPr>
+          <p:cNvPr id="28" name="Text 26"/>
+          <p:cNvSpPr/>
+          <p:nvPr/>
+        </p:nvSpPr>
+        <p:spPr>
+          <a:xfrm>
+            <a:off x="3008376" y="4581144"/>
+            <a:ext cx="1207008" cy="146304"/>
+          </a:xfrm>
+          <a:prstGeom prst="rect">
+            <a:avLst/>
+          </a:prstGeom>
+          <a:noFill/>
+          <a:ln/>
+        </p:spPr>
+        <p:txBody>
+          <a:bodyPr wrap="square" lIns="0" tIns="0" rIns="0" bIns="0" rtlCol="0" anchor="ctr"/>
+          <a:lstStyle/>
+          <a:p>
+            <a:pPr algn="ctr" indent="0" marL="0">
+              <a:buNone/>
+            </a:pPr>
+            <a:r>
+              <a:rPr lang="en-US" sz="700" dirty="0">
+                <a:solidFill>
+                  <a:srgbClr val="5A5A5A"/>
+                </a:solidFill>
+                <a:latin typeface="Arial" pitchFamily="34" charset="0"/>
+                <a:ea typeface="Arial" pitchFamily="34" charset="-122"/>
+                <a:cs typeface="Arial" pitchFamily="34" charset="-120"/>
+              </a:rPr>
+              <a:t>POC / Build</a:t>
+            </a:r>
+            <a:endParaRPr lang="en-US" sz="700" dirty="0"/>
+          </a:p>
+        </p:txBody>
+      </p:sp>
+      <p:sp>
+        <p:nvSpPr>
+          <p:cNvPr id="29" name="Shape 27"/>
+          <p:cNvSpPr/>
+          <p:nvPr/>
+        </p:nvSpPr>
+        <p:spPr>
+          <a:xfrm>
+            <a:off x="4306824" y="4343400"/>
+            <a:ext cx="1207008" cy="420624"/>
+          </a:xfrm>
+          <a:prstGeom prst="roundRect">
+            <a:avLst>
+              <a:gd name="adj" fmla="val 21739"/>
+            </a:avLst>
+          </a:prstGeom>
+          <a:solidFill>
+            <a:srgbClr val="F2F5FA"/>
+          </a:solidFill>
+          <a:ln w="12700">
+            <a:solidFill>
+              <a:srgbClr val="D0D0D0"/>
+            </a:solidFill>
+            <a:prstDash val="solid"/>
+          </a:ln>
+        </p:spPr>
+      </p:sp>
+      <p:sp>
+        <p:nvSpPr>
+          <p:cNvPr id="30" name="Text 28"/>
+          <p:cNvSpPr/>
+          <p:nvPr/>
+        </p:nvSpPr>
+        <p:spPr>
+          <a:xfrm>
+            <a:off x="4306824" y="4370832"/>
+            <a:ext cx="1207008" cy="219456"/>
+          </a:xfrm>
+          <a:prstGeom prst="rect">
+            <a:avLst/>
+          </a:prstGeom>
+          <a:noFill/>
+          <a:ln/>
+        </p:spPr>
+        <p:txBody>
+          <a:bodyPr wrap="square" lIns="0" tIns="0" rIns="0" bIns="0" rtlCol="0" anchor="ctr"/>
+          <a:lstStyle/>
+          <a:p>
+            <a:pPr algn="ctr" indent="0" marL="0">
+              <a:buNone/>
+            </a:pPr>
+            <a:r>
+              <a:rPr lang="en-US" sz="1400" b="1" dirty="0">
+                <a:solidFill>
+                  <a:srgbClr val="1B365D"/>
+                </a:solidFill>
+                <a:latin typeface="Arial" pitchFamily="34" charset="0"/>
+                <a:ea typeface="Arial" pitchFamily="34" charset="-122"/>
+                <a:cs typeface="Arial" pitchFamily="34" charset="-120"/>
+              </a:rPr>
+              <a:t>--</a:t>
+            </a:r>
+            <a:endParaRPr lang="en-US" sz="1400" dirty="0"/>
+          </a:p>
+        </p:txBody>
+      </p:sp>
+      <p:sp>
+        <p:nvSpPr>
+          <p:cNvPr id="31" name="Text 29"/>
+          <p:cNvSpPr/>
+          <p:nvPr/>
+        </p:nvSpPr>
+        <p:spPr>
+          <a:xfrm>
+            <a:off x="4306824" y="4581144"/>
+            <a:ext cx="1207008" cy="146304"/>
+          </a:xfrm>
+          <a:prstGeom prst="rect">
+            <a:avLst/>
+          </a:prstGeom>
+          <a:noFill/>
+          <a:ln/>
+        </p:spPr>
+        <p:txBody>
+          <a:bodyPr wrap="square" lIns="0" tIns="0" rIns="0" bIns="0" rtlCol="0" anchor="ctr"/>
+          <a:lstStyle/>
+          <a:p>
+            <a:pPr algn="ctr" indent="0" marL="0">
+              <a:buNone/>
+            </a:pPr>
+            <a:r>
+              <a:rPr lang="en-US" sz="700" dirty="0">
+                <a:solidFill>
+                  <a:srgbClr val="5A5A5A"/>
+                </a:solidFill>
+                <a:latin typeface="Arial" pitchFamily="34" charset="0"/>
+                <a:ea typeface="Arial" pitchFamily="34" charset="-122"/>
+                <a:cs typeface="Arial" pitchFamily="34" charset="-120"/>
+              </a:rPr>
+              <a:t>Discovery</a:t>
+            </a:r>
+            <a:endParaRPr lang="en-US" sz="700" dirty="0"/>
+          </a:p>
+        </p:txBody>
+      </p:sp>
+      <p:sp>
+        <p:nvSpPr>
+          <p:cNvPr id="32" name="Text 30"/>
+          <p:cNvSpPr/>
+          <p:nvPr/>
+        </p:nvSpPr>
+        <p:spPr>
+          <a:xfrm>
+            <a:off x="502920" y="4937760"/>
+            <a:ext cx="5166360" cy="1508760"/>
+          </a:xfrm>
+          <a:prstGeom prst="rect">
+            <a:avLst/>
+          </a:prstGeom>
+          <a:noFill/>
+          <a:ln/>
+        </p:spPr>
+        <p:txBody>
+          <a:bodyPr wrap="square" lIns="0" tIns="0" rIns="0" bIns="0" rtlCol="0" anchor="ctr"/>
+          <a:lstStyle/>
+          <a:p>
+            <a:pPr marL="152400" indent="-152400">
+              <a:spcAft>
+                <a:spcPts val="700"/>
+              </a:spcAft>
+              <a:buSzPct val="100000"/>
+              <a:buChar char="•"/>
+            </a:pPr>
+            <a:r>
+              <a:rPr lang="en-US" sz="950" dirty="0">
+                <a:solidFill>
+                  <a:srgbClr val="262626"/>
+                </a:solidFill>
+                <a:latin typeface="Arial" pitchFamily="34" charset="0"/>
+                <a:ea typeface="Arial" pitchFamily="34" charset="-122"/>
+                <a:cs typeface="Arial" pitchFamily="34" charset="-120"/>
+              </a:rPr>
+              <a:t>21 SASA agents, Solman CR-CO and Jira AI Agent running in production</a:t>
+            </a:r>
+            <a:endParaRPr lang="en-US" sz="950" dirty="0"/>
+          </a:p>
+          <a:p>
+            <a:pPr marL="152400" indent="-152400">
+              <a:spcAft>
+                <a:spcPts val="700"/>
+              </a:spcAft>
+              <a:buSzPct val="100000"/>
+              <a:buChar char="•"/>
+            </a:pPr>
+            <a:r>
+              <a:rPr lang="en-US" sz="950" dirty="0">
+                <a:solidFill>
+                  <a:srgbClr val="262626"/>
+                </a:solidFill>
+                <a:latin typeface="Arial" pitchFamily="34" charset="0"/>
+                <a:ea typeface="Arial" pitchFamily="34" charset="-122"/>
+                <a:cs typeface="Arial" pitchFamily="34" charset="-120"/>
+              </a:rPr>
+              <a:t>AI SDLC Agent, AGT-001, in pilot and expanding</a:t>
+            </a:r>
+            <a:endParaRPr lang="en-US" sz="950" dirty="0"/>
+          </a:p>
+          <a:p>
+            <a:pPr marL="152400" indent="-152400">
+              <a:spcAft>
+                <a:spcPts val="700"/>
+              </a:spcAft>
+              <a:buSzPct val="100000"/>
+              <a:buChar char="•"/>
+            </a:pPr>
+            <a:r>
+              <a:rPr lang="en-US" sz="950" dirty="0">
+                <a:solidFill>
+                  <a:srgbClr val="262626"/>
+                </a:solidFill>
+                <a:latin typeface="Arial" pitchFamily="34" charset="0"/>
+                <a:ea typeface="Arial" pitchFamily="34" charset="-122"/>
+                <a:cs typeface="Arial" pitchFamily="34" charset="-120"/>
+              </a:rPr>
+              <a:t>Test automation family, AGT-016 to AGT-021, in POC and build</a:t>
+            </a:r>
+            <a:endParaRPr lang="en-US" sz="950" dirty="0"/>
+          </a:p>
+          <a:p>
+            <a:pPr marL="152400" indent="-152400">
+              <a:spcAft>
+                <a:spcPts val="700"/>
+              </a:spcAft>
+              <a:buSzPct val="100000"/>
+              <a:buChar char="•"/>
+            </a:pPr>
+            <a:r>
+              <a:rPr lang="en-US" sz="950" dirty="0">
+                <a:solidFill>
+                  <a:srgbClr val="262626"/>
+                </a:solidFill>
+                <a:latin typeface="Arial" pitchFamily="34" charset="0"/>
+                <a:ea typeface="Arial" pitchFamily="34" charset="-122"/>
+                <a:cs typeface="Arial" pitchFamily="34" charset="-120"/>
+              </a:rPr>
+              <a:t>BTP Integration agents, AGT-013 to AGT-015, in discovery</a:t>
+            </a:r>
+            <a:endParaRPr lang="en-US" sz="950" dirty="0"/>
+          </a:p>
+          <a:p>
+            <a:pPr marL="152400" indent="-152400">
+              <a:spcAft>
+                <a:spcPts val="700"/>
+              </a:spcAft>
+              <a:buSzPct val="100000"/>
+              <a:buChar char="•"/>
+            </a:pPr>
+            <a:r>
+              <a:rPr lang="en-US" sz="950" dirty="0">
+                <a:solidFill>
+                  <a:srgbClr val="262626"/>
+                </a:solidFill>
+                <a:latin typeface="Arial" pitchFamily="34" charset="0"/>
+                <a:ea typeface="Arial" pitchFamily="34" charset="-122"/>
+                <a:cs typeface="Arial" pitchFamily="34" charset="-120"/>
+              </a:rPr>
+              <a:t>New agent teams present weekly at the Community of Practice</a:t>
+            </a:r>
+            <a:endParaRPr lang="en-US" sz="950" dirty="0"/>
+          </a:p>
+        </p:txBody>
+      </p:sp>
+      <p:sp>
+        <p:nvSpPr>
+          <p:cNvPr id="33" name="Shape 31"/>
+          <p:cNvSpPr/>
+          <p:nvPr/>
+        </p:nvSpPr>
+        <p:spPr>
+          <a:xfrm>
+            <a:off x="6126480" y="3794760"/>
+            <a:ext cx="3108960" cy="365760"/>
           </a:xfrm>
           <a:prstGeom prst="roundRect">
             <a:avLst>
@@ -4491,11 +4914,11 @@
             </a:avLst>
           </a:prstGeom>
           <a:solidFill>
-            <a:srgbClr val="D50000"/>
+            <a:srgbClr val="1B365D"/>
           </a:solidFill>
           <a:ln w="12700">
             <a:solidFill>
-              <a:srgbClr val="D50000"/>
+              <a:srgbClr val="1B365D"/>
             </a:solidFill>
             <a:prstDash val="solid"/>
           </a:ln>
@@ -4503,14 +4926,14 @@
       </p:sp>
       <p:sp>
         <p:nvSpPr>
-          <p:cNvPr id="22" name="Text 20"/>
-          <p:cNvSpPr/>
-          <p:nvPr/>
-        </p:nvSpPr>
-        <p:spPr>
-          <a:xfrm>
-            <a:off x="548640" y="4800600"/>
-            <a:ext cx="2377440" cy="274320"/>
+          <p:cNvPr id="34" name="Text 32"/>
+          <p:cNvSpPr/>
+          <p:nvPr/>
+        </p:nvSpPr>
+        <p:spPr>
+          <a:xfrm>
+            <a:off x="6126480" y="3794760"/>
+            <a:ext cx="3108960" cy="365760"/>
           </a:xfrm>
           <a:prstGeom prst="rect">
             <a:avLst/>
@@ -4526,15 +4949,79 @@
               <a:buNone/>
             </a:pPr>
             <a:r>
+              <a:rPr lang="en-US" sz="1200" b="1" dirty="0">
+                <a:solidFill>
+                  <a:srgbClr val="FFFFFF"/>
+                </a:solidFill>
+                <a:latin typeface="Arial" pitchFamily="34" charset="0"/>
+                <a:ea typeface="Arial" pitchFamily="34" charset="-122"/>
+                <a:cs typeface="Arial" pitchFamily="34" charset="-120"/>
+              </a:rPr>
+              <a:t>MVP2 Capabilities, 11 in Flight</a:t>
+            </a:r>
+            <a:endParaRPr lang="en-US" sz="1200" dirty="0"/>
+          </a:p>
+        </p:txBody>
+      </p:sp>
+      <p:sp>
+        <p:nvSpPr>
+          <p:cNvPr id="35" name="Shape 33"/>
+          <p:cNvSpPr/>
+          <p:nvPr/>
+        </p:nvSpPr>
+        <p:spPr>
+          <a:xfrm>
+            <a:off x="6126480" y="4206240"/>
+            <a:ext cx="5760720" cy="2331720"/>
+          </a:xfrm>
+          <a:prstGeom prst="rect">
+            <a:avLst/>
+          </a:prstGeom>
+          <a:solidFill>
+            <a:srgbClr val="FFFFFF"/>
+          </a:solidFill>
+          <a:ln w="9525">
+            <a:solidFill>
+              <a:srgbClr val="D0D0D0"/>
+            </a:solidFill>
+            <a:prstDash val="solid"/>
+          </a:ln>
+        </p:spPr>
+      </p:sp>
+      <p:sp>
+        <p:nvSpPr>
+          <p:cNvPr id="36" name="Text 34"/>
+          <p:cNvSpPr/>
+          <p:nvPr/>
+        </p:nvSpPr>
+        <p:spPr>
+          <a:xfrm>
+            <a:off x="6309360" y="4343400"/>
+            <a:ext cx="2743200" cy="182880"/>
+          </a:xfrm>
+          <a:prstGeom prst="rect">
+            <a:avLst/>
+          </a:prstGeom>
+          <a:noFill/>
+          <a:ln/>
+        </p:spPr>
+        <p:txBody>
+          <a:bodyPr wrap="square" lIns="0" tIns="0" rIns="0" bIns="0" rtlCol="0" anchor="ctr"/>
+          <a:lstStyle/>
+          <a:p>
+            <a:pPr indent="0" marL="0">
+              <a:buNone/>
+            </a:pPr>
+            <a:r>
               <a:rPr lang="en-US" sz="950" b="1" dirty="0">
                 <a:solidFill>
-                  <a:srgbClr val="FFFFFF"/>
-                </a:solidFill>
-                <a:latin typeface="Arial" pitchFamily="34" charset="0"/>
-                <a:ea typeface="Arial" pitchFamily="34" charset="-122"/>
-                <a:cs typeface="Arial" pitchFamily="34" charset="-120"/>
-              </a:rPr>
-              <a:t>Q1 2027</a:t>
+                  <a:srgbClr val="1B365D"/>
+                </a:solidFill>
+                <a:latin typeface="Arial" pitchFamily="34" charset="0"/>
+                <a:ea typeface="Arial" pitchFamily="34" charset="-122"/>
+                <a:cs typeface="Arial" pitchFamily="34" charset="-120"/>
+              </a:rPr>
+              <a:t>Enterprise owned  (6)</a:t>
             </a:r>
             <a:endParaRPr lang="en-US" sz="950" dirty="0"/>
           </a:p>
@@ -4542,14 +5029,14 @@
       </p:sp>
       <p:sp>
         <p:nvSpPr>
-          <p:cNvPr id="23" name="Text 21"/>
-          <p:cNvSpPr/>
-          <p:nvPr/>
-        </p:nvSpPr>
-        <p:spPr>
-          <a:xfrm>
-            <a:off x="658368" y="5193792"/>
-            <a:ext cx="2468880" cy="1188720"/>
+          <p:cNvPr id="37" name="Text 35"/>
+          <p:cNvSpPr/>
+          <p:nvPr/>
+        </p:nvSpPr>
+        <p:spPr>
+          <a:xfrm>
+            <a:off x="6446520" y="4572000"/>
+            <a:ext cx="2697480" cy="1783080"/>
           </a:xfrm>
           <a:prstGeom prst="rect">
             <a:avLst/>
@@ -4577,7 +5064,7 @@
                 <a:ea typeface="Arial" pitchFamily="34" charset="-122"/>
                 <a:cs typeface="Arial" pitchFamily="34" charset="-120"/>
               </a:rPr>
-              <a:t>Second Party federated onboarding</a:t>
+              <a:t>Observability</a:t>
             </a:r>
             <a:endParaRPr lang="en-US" sz="900" dirty="0"/>
           </a:p>
@@ -4598,7 +5085,7 @@
                 <a:ea typeface="Arial" pitchFamily="34" charset="-122"/>
                 <a:cs typeface="Arial" pitchFamily="34" charset="-120"/>
               </a:rPr>
-              <a:t>Value realization dashboard</a:t>
+              <a:t>FinOps</a:t>
             </a:r>
             <a:endParaRPr lang="en-US" sz="900" dirty="0"/>
           </a:p>
@@ -4619,7 +5106,7 @@
                 <a:ea typeface="Arial" pitchFamily="34" charset="-122"/>
                 <a:cs typeface="Arial" pitchFamily="34" charset="-120"/>
               </a:rPr>
-              <a:t>L1 and L2 support tiers</a:t>
+              <a:t>Enterprise Agent / MCP / Skills Registry</a:t>
             </a:r>
             <a:endParaRPr lang="en-US" sz="900" dirty="0"/>
           </a:p>
@@ -4640,98 +5127,10 @@
                 <a:ea typeface="Arial" pitchFamily="34" charset="-122"/>
                 <a:cs typeface="Arial" pitchFamily="34" charset="-120"/>
               </a:rPr>
-              <a:t>MVP3 scope lock</a:t>
+              <a:t>EVALS Framework</a:t>
             </a:r>
             <a:endParaRPr lang="en-US" sz="900" dirty="0"/>
           </a:p>
-        </p:txBody>
-      </p:sp>
-      <p:sp>
-        <p:nvSpPr>
-          <p:cNvPr id="24" name="Shape 22"/>
-          <p:cNvSpPr/>
-          <p:nvPr/>
-        </p:nvSpPr>
-        <p:spPr>
-          <a:xfrm>
-            <a:off x="3383280" y="4800600"/>
-            <a:ext cx="2377440" cy="274320"/>
-          </a:xfrm>
-          <a:prstGeom prst="roundRect">
-            <a:avLst>
-              <a:gd name="adj" fmla="val 50000"/>
-            </a:avLst>
-          </a:prstGeom>
-          <a:solidFill>
-            <a:srgbClr val="D50000"/>
-          </a:solidFill>
-          <a:ln w="12700">
-            <a:solidFill>
-              <a:srgbClr val="D50000"/>
-            </a:solidFill>
-            <a:prstDash val="solid"/>
-          </a:ln>
-        </p:spPr>
-      </p:sp>
-      <p:sp>
-        <p:nvSpPr>
-          <p:cNvPr id="25" name="Text 23"/>
-          <p:cNvSpPr/>
-          <p:nvPr/>
-        </p:nvSpPr>
-        <p:spPr>
-          <a:xfrm>
-            <a:off x="3383280" y="4800600"/>
-            <a:ext cx="2377440" cy="274320"/>
-          </a:xfrm>
-          <a:prstGeom prst="rect">
-            <a:avLst/>
-          </a:prstGeom>
-          <a:noFill/>
-          <a:ln/>
-        </p:spPr>
-        <p:txBody>
-          <a:bodyPr wrap="square" lIns="0" tIns="0" rIns="0" bIns="0" rtlCol="0" anchor="ctr"/>
-          <a:lstStyle/>
-          <a:p>
-            <a:pPr algn="ctr" indent="0" marL="0">
-              <a:buNone/>
-            </a:pPr>
-            <a:r>
-              <a:rPr lang="en-US" sz="950" b="1" dirty="0">
-                <a:solidFill>
-                  <a:srgbClr val="FFFFFF"/>
-                </a:solidFill>
-                <a:latin typeface="Arial" pitchFamily="34" charset="0"/>
-                <a:ea typeface="Arial" pitchFamily="34" charset="-122"/>
-                <a:cs typeface="Arial" pitchFamily="34" charset="-120"/>
-              </a:rPr>
-              <a:t>Q2 2027</a:t>
-            </a:r>
-            <a:endParaRPr lang="en-US" sz="950" dirty="0"/>
-          </a:p>
-        </p:txBody>
-      </p:sp>
-      <p:sp>
-        <p:nvSpPr>
-          <p:cNvPr id="26" name="Text 24"/>
-          <p:cNvSpPr/>
-          <p:nvPr/>
-        </p:nvSpPr>
-        <p:spPr>
-          <a:xfrm>
-            <a:off x="3493008" y="5193792"/>
-            <a:ext cx="2468880" cy="1188720"/>
-          </a:xfrm>
-          <a:prstGeom prst="rect">
-            <a:avLst/>
-          </a:prstGeom>
-          <a:noFill/>
-          <a:ln/>
-        </p:spPr>
-        <p:txBody>
-          <a:bodyPr wrap="square" lIns="0" tIns="0" rIns="0" bIns="0" rtlCol="0" anchor="ctr"/>
-          <a:lstStyle/>
           <a:p>
             <a:pPr marL="152400" indent="-152400">
               <a:spcAft>
@@ -4749,7 +5148,7 @@
                 <a:ea typeface="Arial" pitchFamily="34" charset="-122"/>
                 <a:cs typeface="Arial" pitchFamily="34" charset="-120"/>
               </a:rPr>
-              <a:t>Enterprise catalog discovery</a:t>
+              <a:t>Agent Core Enhancements</a:t>
             </a:r>
             <a:endParaRPr lang="en-US" sz="900" dirty="0"/>
           </a:p>
@@ -4770,10 +5169,71 @@
                 <a:ea typeface="Arial" pitchFamily="34" charset="-122"/>
                 <a:cs typeface="Arial" pitchFamily="34" charset="-120"/>
               </a:rPr>
-              <a:t>Ambient SDLC agents</a:t>
+              <a:t>Context Engineering</a:t>
             </a:r>
             <a:endParaRPr lang="en-US" sz="900" dirty="0"/>
           </a:p>
+        </p:txBody>
+      </p:sp>
+      <p:sp>
+        <p:nvSpPr>
+          <p:cNvPr id="38" name="Text 36"/>
+          <p:cNvSpPr/>
+          <p:nvPr/>
+        </p:nvSpPr>
+        <p:spPr>
+          <a:xfrm>
+            <a:off x="9189720" y="4343400"/>
+            <a:ext cx="2651760" cy="182880"/>
+          </a:xfrm>
+          <a:prstGeom prst="rect">
+            <a:avLst/>
+          </a:prstGeom>
+          <a:noFill/>
+          <a:ln/>
+        </p:spPr>
+        <p:txBody>
+          <a:bodyPr wrap="square" lIns="0" tIns="0" rIns="0" bIns="0" rtlCol="0" anchor="ctr"/>
+          <a:lstStyle/>
+          <a:p>
+            <a:pPr indent="0" marL="0">
+              <a:buNone/>
+            </a:pPr>
+            <a:r>
+              <a:rPr lang="en-US" sz="950" b="1" dirty="0">
+                <a:solidFill>
+                  <a:srgbClr val="D50000"/>
+                </a:solidFill>
+                <a:latin typeface="Arial" pitchFamily="34" charset="0"/>
+                <a:ea typeface="Arial" pitchFamily="34" charset="-122"/>
+                <a:cs typeface="Arial" pitchFamily="34" charset="-120"/>
+              </a:rPr>
+              <a:t>AI SDLC owned  (5)</a:t>
+            </a:r>
+            <a:endParaRPr lang="en-US" sz="950" dirty="0"/>
+          </a:p>
+        </p:txBody>
+      </p:sp>
+      <p:sp>
+        <p:nvSpPr>
+          <p:cNvPr id="39" name="Text 37"/>
+          <p:cNvSpPr/>
+          <p:nvPr/>
+        </p:nvSpPr>
+        <p:spPr>
+          <a:xfrm>
+            <a:off x="9326880" y="4572000"/>
+            <a:ext cx="2514600" cy="1783080"/>
+          </a:xfrm>
+          <a:prstGeom prst="rect">
+            <a:avLst/>
+          </a:prstGeom>
+          <a:noFill/>
+          <a:ln/>
+        </p:spPr>
+        <p:txBody>
+          <a:bodyPr wrap="square" lIns="0" tIns="0" rIns="0" bIns="0" rtlCol="0" anchor="ctr"/>
+          <a:lstStyle/>
           <a:p>
             <a:pPr marL="152400" indent="-152400">
               <a:spcAft>
@@ -4791,98 +5251,10 @@
                 <a:ea typeface="Arial" pitchFamily="34" charset="-122"/>
                 <a:cs typeface="Arial" pitchFamily="34" charset="-120"/>
               </a:rPr>
-              <a:t>SDLC Gen and Code Review Agents</a:t>
+              <a:t>CopilotKit / AG-UI Enhancements</a:t>
             </a:r>
             <a:endParaRPr lang="en-US" sz="900" dirty="0"/>
           </a:p>
-        </p:txBody>
-      </p:sp>
-      <p:sp>
-        <p:nvSpPr>
-          <p:cNvPr id="27" name="Shape 25"/>
-          <p:cNvSpPr/>
-          <p:nvPr/>
-        </p:nvSpPr>
-        <p:spPr>
-          <a:xfrm>
-            <a:off x="6217920" y="4800600"/>
-            <a:ext cx="2377440" cy="274320"/>
-          </a:xfrm>
-          <a:prstGeom prst="roundRect">
-            <a:avLst>
-              <a:gd name="adj" fmla="val 50000"/>
-            </a:avLst>
-          </a:prstGeom>
-          <a:solidFill>
-            <a:srgbClr val="D50000"/>
-          </a:solidFill>
-          <a:ln w="12700">
-            <a:solidFill>
-              <a:srgbClr val="D50000"/>
-            </a:solidFill>
-            <a:prstDash val="solid"/>
-          </a:ln>
-        </p:spPr>
-      </p:sp>
-      <p:sp>
-        <p:nvSpPr>
-          <p:cNvPr id="28" name="Text 26"/>
-          <p:cNvSpPr/>
-          <p:nvPr/>
-        </p:nvSpPr>
-        <p:spPr>
-          <a:xfrm>
-            <a:off x="6217920" y="4800600"/>
-            <a:ext cx="2377440" cy="274320"/>
-          </a:xfrm>
-          <a:prstGeom prst="rect">
-            <a:avLst/>
-          </a:prstGeom>
-          <a:noFill/>
-          <a:ln/>
-        </p:spPr>
-        <p:txBody>
-          <a:bodyPr wrap="square" lIns="0" tIns="0" rIns="0" bIns="0" rtlCol="0" anchor="ctr"/>
-          <a:lstStyle/>
-          <a:p>
-            <a:pPr algn="ctr" indent="0" marL="0">
-              <a:buNone/>
-            </a:pPr>
-            <a:r>
-              <a:rPr lang="en-US" sz="950" b="1" dirty="0">
-                <a:solidFill>
-                  <a:srgbClr val="FFFFFF"/>
-                </a:solidFill>
-                <a:latin typeface="Arial" pitchFamily="34" charset="0"/>
-                <a:ea typeface="Arial" pitchFamily="34" charset="-122"/>
-                <a:cs typeface="Arial" pitchFamily="34" charset="-120"/>
-              </a:rPr>
-              <a:t>Q3 2027</a:t>
-            </a:r>
-            <a:endParaRPr lang="en-US" sz="950" dirty="0"/>
-          </a:p>
-        </p:txBody>
-      </p:sp>
-      <p:sp>
-        <p:nvSpPr>
-          <p:cNvPr id="29" name="Text 27"/>
-          <p:cNvSpPr/>
-          <p:nvPr/>
-        </p:nvSpPr>
-        <p:spPr>
-          <a:xfrm>
-            <a:off x="6327648" y="5193792"/>
-            <a:ext cx="2468880" cy="1188720"/>
-          </a:xfrm>
-          <a:prstGeom prst="rect">
-            <a:avLst/>
-          </a:prstGeom>
-          <a:noFill/>
-          <a:ln/>
-        </p:spPr>
-        <p:txBody>
-          <a:bodyPr wrap="square" lIns="0" tIns="0" rIns="0" bIns="0" rtlCol="0" anchor="ctr"/>
-          <a:lstStyle/>
           <a:p>
             <a:pPr marL="152400" indent="-152400">
               <a:spcAft>
@@ -4900,7 +5272,7 @@
                 <a:ea typeface="Arial" pitchFamily="34" charset="-122"/>
                 <a:cs typeface="Arial" pitchFamily="34" charset="-120"/>
               </a:rPr>
-              <a:t>Third Party integration pattern</a:t>
+              <a:t>Drag &amp; Drop UI for Temporal</a:t>
             </a:r>
             <a:endParaRPr lang="en-US" sz="900" dirty="0"/>
           </a:p>
@@ -4921,98 +5293,10 @@
                 <a:ea typeface="Arial" pitchFamily="34" charset="-122"/>
                 <a:cs typeface="Arial" pitchFamily="34" charset="-120"/>
               </a:rPr>
-              <a:t>Self-service workflow builder GA</a:t>
+              <a:t>Agent Scoring</a:t>
             </a:r>
             <a:endParaRPr lang="en-US" sz="900" dirty="0"/>
           </a:p>
-        </p:txBody>
-      </p:sp>
-      <p:sp>
-        <p:nvSpPr>
-          <p:cNvPr id="30" name="Shape 28"/>
-          <p:cNvSpPr/>
-          <p:nvPr/>
-        </p:nvSpPr>
-        <p:spPr>
-          <a:xfrm>
-            <a:off x="9052560" y="4800600"/>
-            <a:ext cx="2377440" cy="274320"/>
-          </a:xfrm>
-          <a:prstGeom prst="roundRect">
-            <a:avLst>
-              <a:gd name="adj" fmla="val 50000"/>
-            </a:avLst>
-          </a:prstGeom>
-          <a:solidFill>
-            <a:srgbClr val="D50000"/>
-          </a:solidFill>
-          <a:ln w="12700">
-            <a:solidFill>
-              <a:srgbClr val="D50000"/>
-            </a:solidFill>
-            <a:prstDash val="solid"/>
-          </a:ln>
-        </p:spPr>
-      </p:sp>
-      <p:sp>
-        <p:nvSpPr>
-          <p:cNvPr id="31" name="Text 29"/>
-          <p:cNvSpPr/>
-          <p:nvPr/>
-        </p:nvSpPr>
-        <p:spPr>
-          <a:xfrm>
-            <a:off x="9052560" y="4800600"/>
-            <a:ext cx="2377440" cy="274320"/>
-          </a:xfrm>
-          <a:prstGeom prst="rect">
-            <a:avLst/>
-          </a:prstGeom>
-          <a:noFill/>
-          <a:ln/>
-        </p:spPr>
-        <p:txBody>
-          <a:bodyPr wrap="square" lIns="0" tIns="0" rIns="0" bIns="0" rtlCol="0" anchor="ctr"/>
-          <a:lstStyle/>
-          <a:p>
-            <a:pPr algn="ctr" indent="0" marL="0">
-              <a:buNone/>
-            </a:pPr>
-            <a:r>
-              <a:rPr lang="en-US" sz="950" b="1" dirty="0">
-                <a:solidFill>
-                  <a:srgbClr val="FFFFFF"/>
-                </a:solidFill>
-                <a:latin typeface="Arial" pitchFamily="34" charset="0"/>
-                <a:ea typeface="Arial" pitchFamily="34" charset="-122"/>
-                <a:cs typeface="Arial" pitchFamily="34" charset="-120"/>
-              </a:rPr>
-              <a:t>Q4 2027</a:t>
-            </a:r>
-            <a:endParaRPr lang="en-US" sz="950" dirty="0"/>
-          </a:p>
-        </p:txBody>
-      </p:sp>
-      <p:sp>
-        <p:nvSpPr>
-          <p:cNvPr id="32" name="Text 30"/>
-          <p:cNvSpPr/>
-          <p:nvPr/>
-        </p:nvSpPr>
-        <p:spPr>
-          <a:xfrm>
-            <a:off x="9162288" y="5193792"/>
-            <a:ext cx="2468880" cy="1188720"/>
-          </a:xfrm>
-          <a:prstGeom prst="rect">
-            <a:avLst/>
-          </a:prstGeom>
-          <a:noFill/>
-          <a:ln/>
-        </p:spPr>
-        <p:txBody>
-          <a:bodyPr wrap="square" lIns="0" tIns="0" rIns="0" bIns="0" rtlCol="0" anchor="ctr"/>
-          <a:lstStyle/>
           <a:p>
             <a:pPr marL="152400" indent="-152400">
               <a:spcAft>
@@ -5030,7 +5314,7 @@
                 <a:ea typeface="Arial" pitchFamily="34" charset="-122"/>
                 <a:cs typeface="Arial" pitchFamily="34" charset="-120"/>
               </a:rPr>
-              <a:t>AI-assisted platform engineering</a:t>
+              <a:t>Red Team AI Security Studio</a:t>
             </a:r>
             <a:endParaRPr lang="en-US" sz="900" dirty="0"/>
           </a:p>
@@ -5051,7 +5335,7 @@
                 <a:ea typeface="Arial" pitchFamily="34" charset="-122"/>
                 <a:cs typeface="Arial" pitchFamily="34" charset="-120"/>
               </a:rPr>
-              <a:t>Platform maturity assessment</a:t>
+              <a:t>Reports &amp; Dashboard Enhancements</a:t>
             </a:r>
             <a:endParaRPr lang="en-US" sz="900" dirty="0"/>
           </a:p>
@@ -5059,7 +5343,7 @@
       </p:sp>
       <p:sp>
         <p:nvSpPr>
-          <p:cNvPr id="33" name="Text 31"/>
+          <p:cNvPr id="40" name="Text 38"/>
           <p:cNvSpPr/>
           <p:nvPr/>
         </p:nvSpPr>
@@ -5098,7 +5382,7 @@
       </p:sp>
       <p:sp>
         <p:nvSpPr>
-          <p:cNvPr id="34" name="Text 32"/>
+          <p:cNvPr id="41" name="Text 39"/>
           <p:cNvSpPr/>
           <p:nvPr/>
         </p:nvSpPr>

</xml_diff>